<commit_message>
Consolidate pitch to 4 slides; LangSmith as expansion only
Hook, live HF demo, why/expand (LangSmith for import/debug analysis),
and close. No LangChain/LangSmith demo in the main talk track.

Co-authored-by: Jason N. Lim <jhhlim@users.noreply.github.com>
</commit_message>
<xml_diff>
--- a/Jason_Lim_Project_Notes_Demo_10min_VC_Pitch.pptx
+++ b/Jason_Lim_Project_Notes_Demo_10min_VC_Pitch.pptx
@@ -9,13 +9,6 @@
     <p:sldId id="257" r:id="rId8"/>
     <p:sldId id="258" r:id="rId9"/>
     <p:sldId id="259" r:id="rId10"/>
-    <p:sldId id="260" r:id="rId11"/>
-    <p:sldId id="261" r:id="rId12"/>
-    <p:sldId id="262" r:id="rId13"/>
-    <p:sldId id="263" r:id="rId14"/>
-    <p:sldId id="264" r:id="rId15"/>
-    <p:sldId id="265" r:id="rId16"/>
-    <p:sldId id="266" r:id="rId17"/>
   </p:sldIdLst>
   <p:sldSz cx="12191695" cy="6858000" type="screen4x3"/>
   <p:notesSz cx="6858000" cy="9144000"/>
@@ -3192,7 +3185,7 @@
         </p:nvSpPr>
         <p:spPr>
           <a:xfrm>
-            <a:off x="640080" y="1371600"/>
+            <a:off x="640080" y="1280160"/>
             <a:ext cx="10515600" cy="365760"/>
           </a:xfrm>
           <a:prstGeom prst="rect">
@@ -3206,7 +3199,6 @@
           </a:bodyPr>
           <a:lstStyle/>
           <a:p>
-            <a:pPr algn="l"/>
             <a:r>
               <a:rPr sz="1200" b="1">
                 <a:solidFill>
@@ -3214,7 +3206,7 @@
                 </a:solidFill>
                 <a:latin typeface="Arial"/>
               </a:rPr>
-              <a:t>PROJECT NOTES DEMO | 10 MINUTES</a:t>
+              <a:t>PROJECT NOTES DEMO · ~10 MIN</a:t>
             </a:r>
           </a:p>
         </p:txBody>
@@ -3227,8 +3219,8 @@
         </p:nvSpPr>
         <p:spPr>
           <a:xfrm>
-            <a:off x="640080" y="2011680"/>
-            <a:ext cx="10515600" cy="1371600"/>
+            <a:off x="640080" y="1920240"/>
+            <a:ext cx="10515600" cy="1463040"/>
           </a:xfrm>
           <a:prstGeom prst="rect">
             <a:avLst/>
@@ -3241,15 +3233,14 @@
           </a:bodyPr>
           <a:lstStyle/>
           <a:p>
-            <a:pPr algn="l"/>
-            <a:r>
-              <a:rPr sz="3200" b="1">
+            <a:r>
+              <a:rPr sz="3000" b="1">
                 <a:solidFill>
                   <a:srgbClr val="FFFFFF"/>
                 </a:solidFill>
                 <a:latin typeface="Arial"/>
               </a:rPr>
-              <a:t>Luxury Listing Brochures, Generated in Seconds.</a:t>
+              <a:t>Luxury listing brochures — from a Compass URL, in seconds.</a:t>
             </a:r>
           </a:p>
         </p:txBody>
@@ -3263,7 +3254,7 @@
         <p:spPr>
           <a:xfrm>
             <a:off x="640080" y="3840480"/>
-            <a:ext cx="10515600" cy="1371600"/>
+            <a:ext cx="10515600" cy="1828800"/>
           </a:xfrm>
           <a:prstGeom prst="rect">
             <a:avLst/>
@@ -3276,7 +3267,6 @@
           </a:bodyPr>
           <a:lstStyle/>
           <a:p>
-            <a:pPr algn="l"/>
             <a:r>
               <a:rPr sz="1600" b="0">
                 <a:solidFill>
@@ -3284,7 +3274,7 @@
                 </a:solidFill>
                 <a:latin typeface="Arial"/>
               </a:rPr>
-              <a:t>AI product for Silicon Valley sellers — live on Hugging Face, LangSmith-ready, built by Compass REALTOR Jason Lim.</a:t>
+              <a:t>Pain: hours in Canva. Product: live HF Space (Compass RapidAPI → brochure → Edit → PDF). Builder: Jason Lim, Compass DRE #02444964.</a:t>
             </a:r>
           </a:p>
         </p:txBody>
@@ -3297,7 +3287,419 @@
 </p:sld>
 </file>
 
-<file path=ppt/slides/slide10.xml><?xml version="1.0" encoding="utf-8"?>
+<file path=ppt/slides/slide2.xml><?xml version="1.0" encoding="utf-8"?>
+<p:sld xmlns:a="http://schemas.openxmlformats.org/drawingml/2006/main" xmlns:p="http://schemas.openxmlformats.org/presentationml/2006/main" xmlns:r="http://schemas.openxmlformats.org/officeDocument/2006/relationships">
+  <p:cSld>
+    <p:spTree>
+      <p:nvGrpSpPr>
+        <p:cNvPr id="1" name=""/>
+        <p:cNvGrpSpPr/>
+        <p:nvPr/>
+      </p:nvGrpSpPr>
+      <p:grpSpPr/>
+      <p:sp>
+        <p:nvSpPr>
+          <p:cNvPr id="2" name="Rectangle 1"/>
+          <p:cNvSpPr/>
+          <p:nvPr/>
+        </p:nvSpPr>
+        <p:spPr>
+          <a:xfrm>
+            <a:off x="0" y="0"/>
+            <a:ext cx="12191695" cy="6858000"/>
+          </a:xfrm>
+          <a:prstGeom prst="rect">
+            <a:avLst/>
+          </a:prstGeom>
+          <a:solidFill>
+            <a:srgbClr val="FCFAF6"/>
+          </a:solidFill>
+          <a:ln>
+            <a:noFill/>
+          </a:ln>
+        </p:spPr>
+        <p:style>
+          <a:lnRef idx="1">
+            <a:schemeClr val="accent1"/>
+          </a:lnRef>
+          <a:fillRef idx="3">
+            <a:schemeClr val="accent1"/>
+          </a:fillRef>
+          <a:effectRef idx="2">
+            <a:schemeClr val="accent1"/>
+          </a:effectRef>
+          <a:fontRef idx="minor">
+            <a:schemeClr val="lt1"/>
+          </a:fontRef>
+        </p:style>
+        <p:txBody>
+          <a:bodyPr rtlCol="0" anchor="ctr"/>
+          <a:lstStyle/>
+          <a:p>
+            <a:pPr algn="ctr"/>
+          </a:p>
+        </p:txBody>
+      </p:sp>
+      <p:sp>
+        <p:nvSpPr>
+          <p:cNvPr id="3" name="Rectangle 2"/>
+          <p:cNvSpPr/>
+          <p:nvPr/>
+        </p:nvSpPr>
+        <p:spPr>
+          <a:xfrm>
+            <a:off x="0" y="0"/>
+            <a:ext cx="12191695" cy="91440"/>
+          </a:xfrm>
+          <a:prstGeom prst="rect">
+            <a:avLst/>
+          </a:prstGeom>
+          <a:solidFill>
+            <a:srgbClr val="1F6F78"/>
+          </a:solidFill>
+          <a:ln>
+            <a:noFill/>
+          </a:ln>
+        </p:spPr>
+        <p:style>
+          <a:lnRef idx="1">
+            <a:schemeClr val="accent1"/>
+          </a:lnRef>
+          <a:fillRef idx="3">
+            <a:schemeClr val="accent1"/>
+          </a:fillRef>
+          <a:effectRef idx="2">
+            <a:schemeClr val="accent1"/>
+          </a:effectRef>
+          <a:fontRef idx="minor">
+            <a:schemeClr val="lt1"/>
+          </a:fontRef>
+        </p:style>
+        <p:txBody>
+          <a:bodyPr rtlCol="0" anchor="ctr"/>
+          <a:lstStyle/>
+          <a:p>
+            <a:pPr algn="ctr"/>
+          </a:p>
+        </p:txBody>
+      </p:sp>
+      <p:sp>
+        <p:nvSpPr>
+          <p:cNvPr id="4" name="TextBox 3"/>
+          <p:cNvSpPr txBox="1"/>
+          <p:nvPr/>
+        </p:nvSpPr>
+        <p:spPr>
+          <a:xfrm>
+            <a:off x="640080" y="457200"/>
+            <a:ext cx="10515600" cy="365760"/>
+          </a:xfrm>
+          <a:prstGeom prst="rect">
+            <a:avLst/>
+          </a:prstGeom>
+          <a:noFill/>
+        </p:spPr>
+        <p:txBody>
+          <a:bodyPr wrap="square">
+            <a:spAutoFit/>
+          </a:bodyPr>
+          <a:lstStyle/>
+          <a:p>
+            <a:r>
+              <a:rPr sz="1200" b="1">
+                <a:solidFill>
+                  <a:srgbClr val="1F6F78"/>
+                </a:solidFill>
+                <a:latin typeface="Arial"/>
+              </a:rPr>
+              <a:t>LIVE DEMO — HUGGING FACE</a:t>
+            </a:r>
+          </a:p>
+        </p:txBody>
+      </p:sp>
+      <p:sp>
+        <p:nvSpPr>
+          <p:cNvPr id="5" name="TextBox 4"/>
+          <p:cNvSpPr txBox="1"/>
+          <p:nvPr/>
+        </p:nvSpPr>
+        <p:spPr>
+          <a:xfrm>
+            <a:off x="640080" y="1097280"/>
+            <a:ext cx="10515600" cy="1280160"/>
+          </a:xfrm>
+          <a:prstGeom prst="rect">
+            <a:avLst/>
+          </a:prstGeom>
+          <a:noFill/>
+        </p:spPr>
+        <p:txBody>
+          <a:bodyPr wrap="square">
+            <a:spAutoFit/>
+          </a:bodyPr>
+          <a:lstStyle/>
+          <a:p>
+            <a:r>
+              <a:rPr sz="2800" b="1">
+                <a:solidFill>
+                  <a:srgbClr val="0B1F33"/>
+                </a:solidFill>
+                <a:latin typeface="Arial"/>
+              </a:rPr>
+              <a:t>Screen-share the Space. This is the pitch.</a:t>
+            </a:r>
+          </a:p>
+        </p:txBody>
+      </p:sp>
+      <p:sp>
+        <p:nvSpPr>
+          <p:cNvPr id="6" name="TextBox 5"/>
+          <p:cNvSpPr txBox="1"/>
+          <p:nvPr/>
+        </p:nvSpPr>
+        <p:spPr>
+          <a:xfrm>
+            <a:off x="640080" y="2743200"/>
+            <a:ext cx="10515600" cy="2926080"/>
+          </a:xfrm>
+          <a:prstGeom prst="rect">
+            <a:avLst/>
+          </a:prstGeom>
+          <a:noFill/>
+        </p:spPr>
+        <p:txBody>
+          <a:bodyPr wrap="square">
+            <a:spAutoFit/>
+          </a:bodyPr>
+          <a:lstStyle/>
+          <a:p>
+            <a:r>
+              <a:rPr sz="1700" b="0">
+                <a:solidFill>
+                  <a:srgbClr val="5C6B7A"/>
+                </a:solidFill>
+                <a:latin typeface="Arial"/>
+              </a:rPr>
+              <a:t>Paste Compass URL → Generate (photos + facts) → scroll brochure + Google Map → Edit brochure → Print/PDF. Compass RapidAPI only (not Zillow/Redfin). Space: jasonnlim-listing-brochure-studio-jason-realty.static.hf.space</a:t>
+            </a:r>
+          </a:p>
+        </p:txBody>
+      </p:sp>
+    </p:spTree>
+  </p:cSld>
+  <p:clrMapOvr>
+    <a:masterClrMapping/>
+  </p:clrMapOvr>
+</p:sld>
+</file>
+
+<file path=ppt/slides/slide3.xml><?xml version="1.0" encoding="utf-8"?>
+<p:sld xmlns:a="http://schemas.openxmlformats.org/drawingml/2006/main" xmlns:p="http://schemas.openxmlformats.org/presentationml/2006/main" xmlns:r="http://schemas.openxmlformats.org/officeDocument/2006/relationships">
+  <p:cSld>
+    <p:spTree>
+      <p:nvGrpSpPr>
+        <p:cNvPr id="1" name=""/>
+        <p:cNvGrpSpPr/>
+        <p:nvPr/>
+      </p:nvGrpSpPr>
+      <p:grpSpPr/>
+      <p:sp>
+        <p:nvSpPr>
+          <p:cNvPr id="2" name="Rectangle 1"/>
+          <p:cNvSpPr/>
+          <p:nvPr/>
+        </p:nvSpPr>
+        <p:spPr>
+          <a:xfrm>
+            <a:off x="0" y="0"/>
+            <a:ext cx="12191695" cy="6858000"/>
+          </a:xfrm>
+          <a:prstGeom prst="rect">
+            <a:avLst/>
+          </a:prstGeom>
+          <a:solidFill>
+            <a:srgbClr val="FCFAF6"/>
+          </a:solidFill>
+          <a:ln>
+            <a:noFill/>
+          </a:ln>
+        </p:spPr>
+        <p:style>
+          <a:lnRef idx="1">
+            <a:schemeClr val="accent1"/>
+          </a:lnRef>
+          <a:fillRef idx="3">
+            <a:schemeClr val="accent1"/>
+          </a:fillRef>
+          <a:effectRef idx="2">
+            <a:schemeClr val="accent1"/>
+          </a:effectRef>
+          <a:fontRef idx="minor">
+            <a:schemeClr val="lt1"/>
+          </a:fontRef>
+        </p:style>
+        <p:txBody>
+          <a:bodyPr rtlCol="0" anchor="ctr"/>
+          <a:lstStyle/>
+          <a:p>
+            <a:pPr algn="ctr"/>
+          </a:p>
+        </p:txBody>
+      </p:sp>
+      <p:sp>
+        <p:nvSpPr>
+          <p:cNvPr id="3" name="Rectangle 2"/>
+          <p:cNvSpPr/>
+          <p:nvPr/>
+        </p:nvSpPr>
+        <p:spPr>
+          <a:xfrm>
+            <a:off x="0" y="0"/>
+            <a:ext cx="12191695" cy="91440"/>
+          </a:xfrm>
+          <a:prstGeom prst="rect">
+            <a:avLst/>
+          </a:prstGeom>
+          <a:solidFill>
+            <a:srgbClr val="1F6F78"/>
+          </a:solidFill>
+          <a:ln>
+            <a:noFill/>
+          </a:ln>
+        </p:spPr>
+        <p:style>
+          <a:lnRef idx="1">
+            <a:schemeClr val="accent1"/>
+          </a:lnRef>
+          <a:fillRef idx="3">
+            <a:schemeClr val="accent1"/>
+          </a:fillRef>
+          <a:effectRef idx="2">
+            <a:schemeClr val="accent1"/>
+          </a:effectRef>
+          <a:fontRef idx="minor">
+            <a:schemeClr val="lt1"/>
+          </a:fontRef>
+        </p:style>
+        <p:txBody>
+          <a:bodyPr rtlCol="0" anchor="ctr"/>
+          <a:lstStyle/>
+          <a:p>
+            <a:pPr algn="ctr"/>
+          </a:p>
+        </p:txBody>
+      </p:sp>
+      <p:sp>
+        <p:nvSpPr>
+          <p:cNvPr id="4" name="TextBox 3"/>
+          <p:cNvSpPr txBox="1"/>
+          <p:nvPr/>
+        </p:nvSpPr>
+        <p:spPr>
+          <a:xfrm>
+            <a:off x="640080" y="457200"/>
+            <a:ext cx="10515600" cy="365760"/>
+          </a:xfrm>
+          <a:prstGeom prst="rect">
+            <a:avLst/>
+          </a:prstGeom>
+          <a:noFill/>
+        </p:spPr>
+        <p:txBody>
+          <a:bodyPr wrap="square">
+            <a:spAutoFit/>
+          </a:bodyPr>
+          <a:lstStyle/>
+          <a:p>
+            <a:r>
+              <a:rPr sz="1200" b="1">
+                <a:solidFill>
+                  <a:srgbClr val="1F6F78"/>
+                </a:solidFill>
+                <a:latin typeface="Arial"/>
+              </a:rPr>
+              <a:t>WHY IT WINS · HOW TO EXPAND</a:t>
+            </a:r>
+          </a:p>
+        </p:txBody>
+      </p:sp>
+      <p:sp>
+        <p:nvSpPr>
+          <p:cNvPr id="5" name="TextBox 4"/>
+          <p:cNvSpPr txBox="1"/>
+          <p:nvPr/>
+        </p:nvSpPr>
+        <p:spPr>
+          <a:xfrm>
+            <a:off x="640080" y="1097280"/>
+            <a:ext cx="10515600" cy="1280160"/>
+          </a:xfrm>
+          <a:prstGeom prst="rect">
+            <a:avLst/>
+          </a:prstGeom>
+          <a:noFill/>
+        </p:spPr>
+        <p:txBody>
+          <a:bodyPr wrap="square">
+            <a:spAutoFit/>
+          </a:bodyPr>
+          <a:lstStyle/>
+          <a:p>
+            <a:r>
+              <a:rPr sz="2800" b="1">
+                <a:solidFill>
+                  <a:srgbClr val="0B1F33"/>
+                </a:solidFill>
+                <a:latin typeface="Arial"/>
+              </a:rPr>
+              <a:t>Beachhead: brochure. Company: listing OS.</a:t>
+            </a:r>
+          </a:p>
+        </p:txBody>
+      </p:sp>
+      <p:sp>
+        <p:nvSpPr>
+          <p:cNvPr id="6" name="TextBox 5"/>
+          <p:cNvSpPr txBox="1"/>
+          <p:nvPr/>
+        </p:nvSpPr>
+        <p:spPr>
+          <a:xfrm>
+            <a:off x="640080" y="2743200"/>
+            <a:ext cx="10515600" cy="2926080"/>
+          </a:xfrm>
+          <a:prstGeom prst="rect">
+            <a:avLst/>
+          </a:prstGeom>
+          <a:noFill/>
+        </p:spPr>
+        <p:txBody>
+          <a:bodyPr wrap="square">
+            <a:spAutoFit/>
+          </a:bodyPr>
+          <a:lstStyle/>
+          <a:p>
+            <a:r>
+              <a:rPr sz="1700" b="0">
+                <a:solidFill>
+                  <a:srgbClr val="5C6B7A"/>
+                </a:solidFill>
+                <a:latin typeface="Arial"/>
+              </a:rPr>
+              <a:t>Why: distribution at listing appointments, workflow wedge, licensed-agent trust, shipped HF Space. Expand: LangSmith to debug import gaps (missing photos/facts) and brochure quality; LLM copy polish; MLS/IDX + seller share links. Ask: design partners + advisors.</a:t>
+            </a:r>
+          </a:p>
+        </p:txBody>
+      </p:sp>
+    </p:spTree>
+  </p:cSld>
+  <p:clrMapOvr>
+    <a:masterClrMapping/>
+  </p:clrMapOvr>
+</p:sld>
+</file>
+
+<file path=ppt/slides/slide4.xml><?xml version="1.0" encoding="utf-8"?>
 <p:sld xmlns:a="http://schemas.openxmlformats.org/drawingml/2006/main" xmlns:p="http://schemas.openxmlformats.org/presentationml/2006/main" xmlns:r="http://schemas.openxmlformats.org/officeDocument/2006/relationships">
   <p:cSld>
     <p:spTree>
@@ -3401,7 +3803,7 @@
         </p:nvSpPr>
         <p:spPr>
           <a:xfrm>
-            <a:off x="640080" y="1371600"/>
+            <a:off x="640080" y="1280160"/>
             <a:ext cx="10515600" cy="365760"/>
           </a:xfrm>
           <a:prstGeom prst="rect">
@@ -3415,216 +3817,6 @@
           </a:bodyPr>
           <a:lstStyle/>
           <a:p>
-            <a:pPr algn="l"/>
-            <a:r>
-              <a:rPr sz="1200" b="1">
-                <a:solidFill>
-                  <a:srgbClr val="B08D57"/>
-                </a:solidFill>
-                <a:latin typeface="Arial"/>
-              </a:rPr>
-              <a:t>THE ASK</a:t>
-            </a:r>
-          </a:p>
-        </p:txBody>
-      </p:sp>
-      <p:sp>
-        <p:nvSpPr>
-          <p:cNvPr id="5" name="TextBox 4"/>
-          <p:cNvSpPr txBox="1"/>
-          <p:nvPr/>
-        </p:nvSpPr>
-        <p:spPr>
-          <a:xfrm>
-            <a:off x="640080" y="2011680"/>
-            <a:ext cx="10515600" cy="1371600"/>
-          </a:xfrm>
-          <a:prstGeom prst="rect">
-            <a:avLst/>
-          </a:prstGeom>
-          <a:noFill/>
-        </p:spPr>
-        <p:txBody>
-          <a:bodyPr wrap="square">
-            <a:spAutoFit/>
-          </a:bodyPr>
-          <a:lstStyle/>
-          <a:p>
-            <a:pPr algn="l"/>
-            <a:r>
-              <a:rPr sz="3200" b="1">
-                <a:solidFill>
-                  <a:srgbClr val="FFFFFF"/>
-                </a:solidFill>
-                <a:latin typeface="Arial"/>
-              </a:rPr>
-              <a:t>Help us turn every listing into a brand moment.</a:t>
-            </a:r>
-          </a:p>
-        </p:txBody>
-      </p:sp>
-      <p:sp>
-        <p:nvSpPr>
-          <p:cNvPr id="6" name="TextBox 5"/>
-          <p:cNvSpPr txBox="1"/>
-          <p:nvPr/>
-        </p:nvSpPr>
-        <p:spPr>
-          <a:xfrm>
-            <a:off x="640080" y="3840480"/>
-            <a:ext cx="10515600" cy="1371600"/>
-          </a:xfrm>
-          <a:prstGeom prst="rect">
-            <a:avLst/>
-          </a:prstGeom>
-          <a:noFill/>
-        </p:spPr>
-        <p:txBody>
-          <a:bodyPr wrap="square">
-            <a:spAutoFit/>
-          </a:bodyPr>
-          <a:lstStyle/>
-          <a:p>
-            <a:pPr algn="l"/>
-            <a:r>
-              <a:rPr sz="1600" b="0">
-                <a:solidFill>
-                  <a:srgbClr val="E8F2F3"/>
-                </a:solidFill>
-                <a:latin typeface="Arial"/>
-              </a:rPr>
-              <a:t>Design partners · LangSmith eval budget · Advisors who scaled agent tooling</a:t>
-            </a:r>
-          </a:p>
-        </p:txBody>
-      </p:sp>
-    </p:spTree>
-  </p:cSld>
-  <p:clrMapOvr>
-    <a:masterClrMapping/>
-  </p:clrMapOvr>
-</p:sld>
-</file>
-
-<file path=ppt/slides/slide11.xml><?xml version="1.0" encoding="utf-8"?>
-<p:sld xmlns:a="http://schemas.openxmlformats.org/drawingml/2006/main" xmlns:p="http://schemas.openxmlformats.org/presentationml/2006/main" xmlns:r="http://schemas.openxmlformats.org/officeDocument/2006/relationships">
-  <p:cSld>
-    <p:spTree>
-      <p:nvGrpSpPr>
-        <p:cNvPr id="1" name=""/>
-        <p:cNvGrpSpPr/>
-        <p:nvPr/>
-      </p:nvGrpSpPr>
-      <p:grpSpPr/>
-      <p:sp>
-        <p:nvSpPr>
-          <p:cNvPr id="2" name="Rectangle 1"/>
-          <p:cNvSpPr/>
-          <p:nvPr/>
-        </p:nvSpPr>
-        <p:spPr>
-          <a:xfrm>
-            <a:off x="0" y="0"/>
-            <a:ext cx="12191695" cy="6858000"/>
-          </a:xfrm>
-          <a:prstGeom prst="rect">
-            <a:avLst/>
-          </a:prstGeom>
-          <a:solidFill>
-            <a:srgbClr val="0B1F33"/>
-          </a:solidFill>
-          <a:ln>
-            <a:noFill/>
-          </a:ln>
-        </p:spPr>
-        <p:style>
-          <a:lnRef idx="1">
-            <a:schemeClr val="accent1"/>
-          </a:lnRef>
-          <a:fillRef idx="3">
-            <a:schemeClr val="accent1"/>
-          </a:fillRef>
-          <a:effectRef idx="2">
-            <a:schemeClr val="accent1"/>
-          </a:effectRef>
-          <a:fontRef idx="minor">
-            <a:schemeClr val="lt1"/>
-          </a:fontRef>
-        </p:style>
-        <p:txBody>
-          <a:bodyPr rtlCol="0" anchor="ctr"/>
-          <a:lstStyle/>
-          <a:p>
-            <a:pPr algn="ctr"/>
-          </a:p>
-        </p:txBody>
-      </p:sp>
-      <p:sp>
-        <p:nvSpPr>
-          <p:cNvPr id="3" name="Rectangle 2"/>
-          <p:cNvSpPr/>
-          <p:nvPr/>
-        </p:nvSpPr>
-        <p:spPr>
-          <a:xfrm>
-            <a:off x="0" y="0"/>
-            <a:ext cx="137160" cy="6858000"/>
-          </a:xfrm>
-          <a:prstGeom prst="rect">
-            <a:avLst/>
-          </a:prstGeom>
-          <a:solidFill>
-            <a:srgbClr val="B08D57"/>
-          </a:solidFill>
-          <a:ln>
-            <a:noFill/>
-          </a:ln>
-        </p:spPr>
-        <p:style>
-          <a:lnRef idx="1">
-            <a:schemeClr val="accent1"/>
-          </a:lnRef>
-          <a:fillRef idx="3">
-            <a:schemeClr val="accent1"/>
-          </a:fillRef>
-          <a:effectRef idx="2">
-            <a:schemeClr val="accent1"/>
-          </a:effectRef>
-          <a:fontRef idx="minor">
-            <a:schemeClr val="lt1"/>
-          </a:fontRef>
-        </p:style>
-        <p:txBody>
-          <a:bodyPr rtlCol="0" anchor="ctr"/>
-          <a:lstStyle/>
-          <a:p>
-            <a:pPr algn="ctr"/>
-          </a:p>
-        </p:txBody>
-      </p:sp>
-      <p:sp>
-        <p:nvSpPr>
-          <p:cNvPr id="4" name="TextBox 3"/>
-          <p:cNvSpPr txBox="1"/>
-          <p:nvPr/>
-        </p:nvSpPr>
-        <p:spPr>
-          <a:xfrm>
-            <a:off x="640080" y="1371600"/>
-            <a:ext cx="10515600" cy="365760"/>
-          </a:xfrm>
-          <a:prstGeom prst="rect">
-            <a:avLst/>
-          </a:prstGeom>
-          <a:noFill/>
-        </p:spPr>
-        <p:txBody>
-          <a:bodyPr wrap="square">
-            <a:spAutoFit/>
-          </a:bodyPr>
-          <a:lstStyle/>
-          <a:p>
-            <a:pPr algn="l"/>
             <a:r>
               <a:rPr sz="1200" b="1">
                 <a:solidFill>
@@ -3645,8 +3837,8 @@
         </p:nvSpPr>
         <p:spPr>
           <a:xfrm>
-            <a:off x="640080" y="2011680"/>
-            <a:ext cx="10515600" cy="1371600"/>
+            <a:off x="640080" y="1920240"/>
+            <a:ext cx="10515600" cy="1463040"/>
           </a:xfrm>
           <a:prstGeom prst="rect">
             <a:avLst/>
@@ -3659,15 +3851,14 @@
           </a:bodyPr>
           <a:lstStyle/>
           <a:p>
-            <a:pPr algn="l"/>
-            <a:r>
-              <a:rPr sz="3200" b="1">
+            <a:r>
+              <a:rPr sz="3000" b="1">
                 <a:solidFill>
                   <a:srgbClr val="FFFFFF"/>
                 </a:solidFill>
                 <a:latin typeface="Arial"/>
               </a:rPr>
-              <a:t>Let's generate the next listing before the open house.</a:t>
+              <a:t>Generate the next listing before the open house.</a:t>
             </a:r>
           </a:p>
         </p:txBody>
@@ -3681,7 +3872,7 @@
         <p:spPr>
           <a:xfrm>
             <a:off x="640080" y="3840480"/>
-            <a:ext cx="10515600" cy="1371600"/>
+            <a:ext cx="10515600" cy="1828800"/>
           </a:xfrm>
           <a:prstGeom prst="rect">
             <a:avLst/>
@@ -3694,7 +3885,6 @@
           </a:bodyPr>
           <a:lstStyle/>
           <a:p>
-            <a:pPr algn="l"/>
             <a:r>
               <a:rPr sz="1600" b="0">
                 <a:solidFill>
@@ -3702,1679 +3892,7 @@
                 </a:solidFill>
                 <a:latin typeface="Arial"/>
               </a:rPr>
-              <a:t>Jason Lim · Compass · DRE #02444964 · jason.lim@compass.com · (510) 480-7191 · jasonlimrealty.com</a:t>
-            </a:r>
-          </a:p>
-        </p:txBody>
-      </p:sp>
-    </p:spTree>
-  </p:cSld>
-  <p:clrMapOvr>
-    <a:masterClrMapping/>
-  </p:clrMapOvr>
-</p:sld>
-</file>
-
-<file path=ppt/slides/slide2.xml><?xml version="1.0" encoding="utf-8"?>
-<p:sld xmlns:a="http://schemas.openxmlformats.org/drawingml/2006/main" xmlns:p="http://schemas.openxmlformats.org/presentationml/2006/main" xmlns:r="http://schemas.openxmlformats.org/officeDocument/2006/relationships">
-  <p:cSld>
-    <p:spTree>
-      <p:nvGrpSpPr>
-        <p:cNvPr id="1" name=""/>
-        <p:cNvGrpSpPr/>
-        <p:nvPr/>
-      </p:nvGrpSpPr>
-      <p:grpSpPr/>
-      <p:sp>
-        <p:nvSpPr>
-          <p:cNvPr id="2" name="Rectangle 1"/>
-          <p:cNvSpPr/>
-          <p:nvPr/>
-        </p:nvSpPr>
-        <p:spPr>
-          <a:xfrm>
-            <a:off x="0" y="0"/>
-            <a:ext cx="12191695" cy="6858000"/>
-          </a:xfrm>
-          <a:prstGeom prst="rect">
-            <a:avLst/>
-          </a:prstGeom>
-          <a:solidFill>
-            <a:srgbClr val="FCFAF6"/>
-          </a:solidFill>
-          <a:ln>
-            <a:noFill/>
-          </a:ln>
-        </p:spPr>
-        <p:style>
-          <a:lnRef idx="1">
-            <a:schemeClr val="accent1"/>
-          </a:lnRef>
-          <a:fillRef idx="3">
-            <a:schemeClr val="accent1"/>
-          </a:fillRef>
-          <a:effectRef idx="2">
-            <a:schemeClr val="accent1"/>
-          </a:effectRef>
-          <a:fontRef idx="minor">
-            <a:schemeClr val="lt1"/>
-          </a:fontRef>
-        </p:style>
-        <p:txBody>
-          <a:bodyPr rtlCol="0" anchor="ctr"/>
-          <a:lstStyle/>
-          <a:p>
-            <a:pPr algn="ctr"/>
-          </a:p>
-        </p:txBody>
-      </p:sp>
-      <p:sp>
-        <p:nvSpPr>
-          <p:cNvPr id="3" name="Rectangle 2"/>
-          <p:cNvSpPr/>
-          <p:nvPr/>
-        </p:nvSpPr>
-        <p:spPr>
-          <a:xfrm>
-            <a:off x="0" y="0"/>
-            <a:ext cx="12191695" cy="91440"/>
-          </a:xfrm>
-          <a:prstGeom prst="rect">
-            <a:avLst/>
-          </a:prstGeom>
-          <a:solidFill>
-            <a:srgbClr val="1F6F78"/>
-          </a:solidFill>
-          <a:ln>
-            <a:noFill/>
-          </a:ln>
-        </p:spPr>
-        <p:style>
-          <a:lnRef idx="1">
-            <a:schemeClr val="accent1"/>
-          </a:lnRef>
-          <a:fillRef idx="3">
-            <a:schemeClr val="accent1"/>
-          </a:fillRef>
-          <a:effectRef idx="2">
-            <a:schemeClr val="accent1"/>
-          </a:effectRef>
-          <a:fontRef idx="minor">
-            <a:schemeClr val="lt1"/>
-          </a:fontRef>
-        </p:style>
-        <p:txBody>
-          <a:bodyPr rtlCol="0" anchor="ctr"/>
-          <a:lstStyle/>
-          <a:p>
-            <a:pPr algn="ctr"/>
-          </a:p>
-        </p:txBody>
-      </p:sp>
-      <p:sp>
-        <p:nvSpPr>
-          <p:cNvPr id="4" name="TextBox 3"/>
-          <p:cNvSpPr txBox="1"/>
-          <p:nvPr/>
-        </p:nvSpPr>
-        <p:spPr>
-          <a:xfrm>
-            <a:off x="640080" y="457200"/>
-            <a:ext cx="10515600" cy="365760"/>
-          </a:xfrm>
-          <a:prstGeom prst="rect">
-            <a:avLst/>
-          </a:prstGeom>
-          <a:noFill/>
-        </p:spPr>
-        <p:txBody>
-          <a:bodyPr wrap="square">
-            <a:spAutoFit/>
-          </a:bodyPr>
-          <a:lstStyle/>
-          <a:p>
-            <a:pPr algn="l"/>
-            <a:r>
-              <a:rPr sz="1200" b="1">
-                <a:solidFill>
-                  <a:srgbClr val="1F6F78"/>
-                </a:solidFill>
-                <a:latin typeface="Arial"/>
-              </a:rPr>
-              <a:t>THE PROBLEM</a:t>
-            </a:r>
-          </a:p>
-        </p:txBody>
-      </p:sp>
-      <p:sp>
-        <p:nvSpPr>
-          <p:cNvPr id="5" name="TextBox 4"/>
-          <p:cNvSpPr txBox="1"/>
-          <p:nvPr/>
-        </p:nvSpPr>
-        <p:spPr>
-          <a:xfrm>
-            <a:off x="640080" y="1097280"/>
-            <a:ext cx="10515600" cy="1280160"/>
-          </a:xfrm>
-          <a:prstGeom prst="rect">
-            <a:avLst/>
-          </a:prstGeom>
-          <a:noFill/>
-        </p:spPr>
-        <p:txBody>
-          <a:bodyPr wrap="square">
-            <a:spAutoFit/>
-          </a:bodyPr>
-          <a:lstStyle/>
-          <a:p>
-            <a:pPr algn="l"/>
-            <a:r>
-              <a:rPr sz="2800" b="1">
-                <a:solidFill>
-                  <a:srgbClr val="0B1F33"/>
-                </a:solidFill>
-                <a:latin typeface="Arial"/>
-              </a:rPr>
-              <a:t>Luxury marketing is stuck in Word docs and Canva chaos.</a:t>
-            </a:r>
-          </a:p>
-        </p:txBody>
-      </p:sp>
-      <p:sp>
-        <p:nvSpPr>
-          <p:cNvPr id="6" name="TextBox 5"/>
-          <p:cNvSpPr txBox="1"/>
-          <p:nvPr/>
-        </p:nvSpPr>
-        <p:spPr>
-          <a:xfrm>
-            <a:off x="640080" y="2743200"/>
-            <a:ext cx="10515600" cy="2286000"/>
-          </a:xfrm>
-          <a:prstGeom prst="rect">
-            <a:avLst/>
-          </a:prstGeom>
-          <a:noFill/>
-        </p:spPr>
-        <p:txBody>
-          <a:bodyPr wrap="square">
-            <a:spAutoFit/>
-          </a:bodyPr>
-          <a:lstStyle/>
-          <a:p>
-            <a:pPr algn="l"/>
-            <a:r>
-              <a:rPr sz="1800" b="0">
-                <a:solidFill>
-                  <a:srgbClr val="5C6B7A"/>
-                </a:solidFill>
-                <a:latin typeface="Arial"/>
-              </a:rPr>
-              <a:t>Slow assembly. Inconsistent brand. No URL-to-brochure product. No observability.</a:t>
-            </a:r>
-          </a:p>
-        </p:txBody>
-      </p:sp>
-    </p:spTree>
-  </p:cSld>
-  <p:clrMapOvr>
-    <a:masterClrMapping/>
-  </p:clrMapOvr>
-</p:sld>
-</file>
-
-<file path=ppt/slides/slide3.xml><?xml version="1.0" encoding="utf-8"?>
-<p:sld xmlns:a="http://schemas.openxmlformats.org/drawingml/2006/main" xmlns:p="http://schemas.openxmlformats.org/presentationml/2006/main" xmlns:r="http://schemas.openxmlformats.org/officeDocument/2006/relationships">
-  <p:cSld>
-    <p:spTree>
-      <p:nvGrpSpPr>
-        <p:cNvPr id="1" name=""/>
-        <p:cNvGrpSpPr/>
-        <p:nvPr/>
-      </p:nvGrpSpPr>
-      <p:grpSpPr/>
-      <p:sp>
-        <p:nvSpPr>
-          <p:cNvPr id="2" name="Rectangle 1"/>
-          <p:cNvSpPr/>
-          <p:nvPr/>
-        </p:nvSpPr>
-        <p:spPr>
-          <a:xfrm>
-            <a:off x="0" y="0"/>
-            <a:ext cx="12191695" cy="6858000"/>
-          </a:xfrm>
-          <a:prstGeom prst="rect">
-            <a:avLst/>
-          </a:prstGeom>
-          <a:solidFill>
-            <a:srgbClr val="FCFAF6"/>
-          </a:solidFill>
-          <a:ln>
-            <a:noFill/>
-          </a:ln>
-        </p:spPr>
-        <p:style>
-          <a:lnRef idx="1">
-            <a:schemeClr val="accent1"/>
-          </a:lnRef>
-          <a:fillRef idx="3">
-            <a:schemeClr val="accent1"/>
-          </a:fillRef>
-          <a:effectRef idx="2">
-            <a:schemeClr val="accent1"/>
-          </a:effectRef>
-          <a:fontRef idx="minor">
-            <a:schemeClr val="lt1"/>
-          </a:fontRef>
-        </p:style>
-        <p:txBody>
-          <a:bodyPr rtlCol="0" anchor="ctr"/>
-          <a:lstStyle/>
-          <a:p>
-            <a:pPr algn="ctr"/>
-          </a:p>
-        </p:txBody>
-      </p:sp>
-      <p:sp>
-        <p:nvSpPr>
-          <p:cNvPr id="3" name="Rectangle 2"/>
-          <p:cNvSpPr/>
-          <p:nvPr/>
-        </p:nvSpPr>
-        <p:spPr>
-          <a:xfrm>
-            <a:off x="0" y="0"/>
-            <a:ext cx="12191695" cy="91440"/>
-          </a:xfrm>
-          <a:prstGeom prst="rect">
-            <a:avLst/>
-          </a:prstGeom>
-          <a:solidFill>
-            <a:srgbClr val="1F6F78"/>
-          </a:solidFill>
-          <a:ln>
-            <a:noFill/>
-          </a:ln>
-        </p:spPr>
-        <p:style>
-          <a:lnRef idx="1">
-            <a:schemeClr val="accent1"/>
-          </a:lnRef>
-          <a:fillRef idx="3">
-            <a:schemeClr val="accent1"/>
-          </a:fillRef>
-          <a:effectRef idx="2">
-            <a:schemeClr val="accent1"/>
-          </a:effectRef>
-          <a:fontRef idx="minor">
-            <a:schemeClr val="lt1"/>
-          </a:fontRef>
-        </p:style>
-        <p:txBody>
-          <a:bodyPr rtlCol="0" anchor="ctr"/>
-          <a:lstStyle/>
-          <a:p>
-            <a:pPr algn="ctr"/>
-          </a:p>
-        </p:txBody>
-      </p:sp>
-      <p:sp>
-        <p:nvSpPr>
-          <p:cNvPr id="4" name="TextBox 3"/>
-          <p:cNvSpPr txBox="1"/>
-          <p:nvPr/>
-        </p:nvSpPr>
-        <p:spPr>
-          <a:xfrm>
-            <a:off x="640080" y="457200"/>
-            <a:ext cx="10515600" cy="365760"/>
-          </a:xfrm>
-          <a:prstGeom prst="rect">
-            <a:avLst/>
-          </a:prstGeom>
-          <a:noFill/>
-        </p:spPr>
-        <p:txBody>
-          <a:bodyPr wrap="square">
-            <a:spAutoFit/>
-          </a:bodyPr>
-          <a:lstStyle/>
-          <a:p>
-            <a:pPr algn="l"/>
-            <a:r>
-              <a:rPr sz="1200" b="1">
-                <a:solidFill>
-                  <a:srgbClr val="1F6F78"/>
-                </a:solidFill>
-                <a:latin typeface="Arial"/>
-              </a:rPr>
-              <a:t>THE PRODUCT</a:t>
-            </a:r>
-          </a:p>
-        </p:txBody>
-      </p:sp>
-      <p:sp>
-        <p:nvSpPr>
-          <p:cNvPr id="5" name="TextBox 4"/>
-          <p:cNvSpPr txBox="1"/>
-          <p:nvPr/>
-        </p:nvSpPr>
-        <p:spPr>
-          <a:xfrm>
-            <a:off x="640080" y="1097280"/>
-            <a:ext cx="10515600" cy="1280160"/>
-          </a:xfrm>
-          <a:prstGeom prst="rect">
-            <a:avLst/>
-          </a:prstGeom>
-          <a:noFill/>
-        </p:spPr>
-        <p:txBody>
-          <a:bodyPr wrap="square">
-            <a:spAutoFit/>
-          </a:bodyPr>
-          <a:lstStyle/>
-          <a:p>
-            <a:pPr algn="l"/>
-            <a:r>
-              <a:rPr sz="2800" b="1">
-                <a:solidFill>
-                  <a:srgbClr val="0B1F33"/>
-                </a:solidFill>
-                <a:latin typeface="Arial"/>
-              </a:rPr>
-              <a:t>URL in. Luxury brochure out.</a:t>
-            </a:r>
-          </a:p>
-        </p:txBody>
-      </p:sp>
-      <p:sp>
-        <p:nvSpPr>
-          <p:cNvPr id="6" name="TextBox 5"/>
-          <p:cNvSpPr txBox="1"/>
-          <p:nvPr/>
-        </p:nvSpPr>
-        <p:spPr>
-          <a:xfrm>
-            <a:off x="640080" y="2743200"/>
-            <a:ext cx="10515600" cy="2286000"/>
-          </a:xfrm>
-          <a:prstGeom prst="rect">
-            <a:avLst/>
-          </a:prstGeom>
-          <a:noFill/>
-        </p:spPr>
-        <p:txBody>
-          <a:bodyPr wrap="square">
-            <a:spAutoFit/>
-          </a:bodyPr>
-          <a:lstStyle/>
-          <a:p>
-            <a:pPr algn="l"/>
-            <a:r>
-              <a:rPr sz="1800" b="0">
-                <a:solidFill>
-                  <a:srgbClr val="5C6B7A"/>
-                </a:solidFill>
-                <a:latin typeface="Arial"/>
-              </a:rPr>
-              <a:t>1) Paste Compass URL  2) Compose brochure  3) Edit photos/facts  4) Print/PDF</a:t>
-            </a:r>
-          </a:p>
-        </p:txBody>
-      </p:sp>
-    </p:spTree>
-  </p:cSld>
-  <p:clrMapOvr>
-    <a:masterClrMapping/>
-  </p:clrMapOvr>
-</p:sld>
-</file>
-
-<file path=ppt/slides/slide4.xml><?xml version="1.0" encoding="utf-8"?>
-<p:sld xmlns:a="http://schemas.openxmlformats.org/drawingml/2006/main" xmlns:p="http://schemas.openxmlformats.org/presentationml/2006/main" xmlns:r="http://schemas.openxmlformats.org/officeDocument/2006/relationships">
-  <p:cSld>
-    <p:spTree>
-      <p:nvGrpSpPr>
-        <p:cNvPr id="1" name=""/>
-        <p:cNvGrpSpPr/>
-        <p:nvPr/>
-      </p:nvGrpSpPr>
-      <p:grpSpPr/>
-      <p:sp>
-        <p:nvSpPr>
-          <p:cNvPr id="2" name="Rectangle 1"/>
-          <p:cNvSpPr/>
-          <p:nvPr/>
-        </p:nvSpPr>
-        <p:spPr>
-          <a:xfrm>
-            <a:off x="0" y="0"/>
-            <a:ext cx="12191695" cy="6858000"/>
-          </a:xfrm>
-          <a:prstGeom prst="rect">
-            <a:avLst/>
-          </a:prstGeom>
-          <a:solidFill>
-            <a:srgbClr val="0B1F33"/>
-          </a:solidFill>
-          <a:ln>
-            <a:noFill/>
-          </a:ln>
-        </p:spPr>
-        <p:style>
-          <a:lnRef idx="1">
-            <a:schemeClr val="accent1"/>
-          </a:lnRef>
-          <a:fillRef idx="3">
-            <a:schemeClr val="accent1"/>
-          </a:fillRef>
-          <a:effectRef idx="2">
-            <a:schemeClr val="accent1"/>
-          </a:effectRef>
-          <a:fontRef idx="minor">
-            <a:schemeClr val="lt1"/>
-          </a:fontRef>
-        </p:style>
-        <p:txBody>
-          <a:bodyPr rtlCol="0" anchor="ctr"/>
-          <a:lstStyle/>
-          <a:p>
-            <a:pPr algn="ctr"/>
-          </a:p>
-        </p:txBody>
-      </p:sp>
-      <p:sp>
-        <p:nvSpPr>
-          <p:cNvPr id="3" name="Rectangle 2"/>
-          <p:cNvSpPr/>
-          <p:nvPr/>
-        </p:nvSpPr>
-        <p:spPr>
-          <a:xfrm>
-            <a:off x="0" y="0"/>
-            <a:ext cx="137160" cy="6858000"/>
-          </a:xfrm>
-          <a:prstGeom prst="rect">
-            <a:avLst/>
-          </a:prstGeom>
-          <a:solidFill>
-            <a:srgbClr val="B08D57"/>
-          </a:solidFill>
-          <a:ln>
-            <a:noFill/>
-          </a:ln>
-        </p:spPr>
-        <p:style>
-          <a:lnRef idx="1">
-            <a:schemeClr val="accent1"/>
-          </a:lnRef>
-          <a:fillRef idx="3">
-            <a:schemeClr val="accent1"/>
-          </a:fillRef>
-          <a:effectRef idx="2">
-            <a:schemeClr val="accent1"/>
-          </a:effectRef>
-          <a:fontRef idx="minor">
-            <a:schemeClr val="lt1"/>
-          </a:fontRef>
-        </p:style>
-        <p:txBody>
-          <a:bodyPr rtlCol="0" anchor="ctr"/>
-          <a:lstStyle/>
-          <a:p>
-            <a:pPr algn="ctr"/>
-          </a:p>
-        </p:txBody>
-      </p:sp>
-      <p:sp>
-        <p:nvSpPr>
-          <p:cNvPr id="4" name="TextBox 3"/>
-          <p:cNvSpPr txBox="1"/>
-          <p:nvPr/>
-        </p:nvSpPr>
-        <p:spPr>
-          <a:xfrm>
-            <a:off x="640080" y="1371600"/>
-            <a:ext cx="10515600" cy="365760"/>
-          </a:xfrm>
-          <a:prstGeom prst="rect">
-            <a:avLst/>
-          </a:prstGeom>
-          <a:noFill/>
-        </p:spPr>
-        <p:txBody>
-          <a:bodyPr wrap="square">
-            <a:spAutoFit/>
-          </a:bodyPr>
-          <a:lstStyle/>
-          <a:p>
-            <a:pPr algn="l"/>
-            <a:r>
-              <a:rPr sz="1200" b="1">
-                <a:solidFill>
-                  <a:srgbClr val="B08D57"/>
-                </a:solidFill>
-                <a:latin typeface="Arial"/>
-              </a:rPr>
-              <a:t>LIVE DEMO | HUGGING FACE</a:t>
-            </a:r>
-          </a:p>
-        </p:txBody>
-      </p:sp>
-      <p:sp>
-        <p:nvSpPr>
-          <p:cNvPr id="5" name="TextBox 4"/>
-          <p:cNvSpPr txBox="1"/>
-          <p:nvPr/>
-        </p:nvSpPr>
-        <p:spPr>
-          <a:xfrm>
-            <a:off x="640080" y="2011680"/>
-            <a:ext cx="10515600" cy="1371600"/>
-          </a:xfrm>
-          <a:prstGeom prst="rect">
-            <a:avLst/>
-          </a:prstGeom>
-          <a:noFill/>
-        </p:spPr>
-        <p:txBody>
-          <a:bodyPr wrap="square">
-            <a:spAutoFit/>
-          </a:bodyPr>
-          <a:lstStyle/>
-          <a:p>
-            <a:pPr algn="l"/>
-            <a:r>
-              <a:rPr sz="3200" b="1">
-                <a:solidFill>
-                  <a:srgbClr val="FFFFFF"/>
-                </a:solidFill>
-                <a:latin typeface="Arial"/>
-              </a:rPr>
-              <a:t>Watch it on the Space.</a:t>
-            </a:r>
-          </a:p>
-        </p:txBody>
-      </p:sp>
-      <p:sp>
-        <p:nvSpPr>
-          <p:cNvPr id="6" name="TextBox 5"/>
-          <p:cNvSpPr txBox="1"/>
-          <p:nvPr/>
-        </p:nvSpPr>
-        <p:spPr>
-          <a:xfrm>
-            <a:off x="640080" y="3840480"/>
-            <a:ext cx="10515600" cy="1371600"/>
-          </a:xfrm>
-          <a:prstGeom prst="rect">
-            <a:avLst/>
-          </a:prstGeom>
-          <a:noFill/>
-        </p:spPr>
-        <p:txBody>
-          <a:bodyPr wrap="square">
-            <a:spAutoFit/>
-          </a:bodyPr>
-          <a:lstStyle/>
-          <a:p>
-            <a:pPr algn="l"/>
-            <a:r>
-              <a:rPr sz="1600" b="0">
-                <a:solidFill>
-                  <a:srgbClr val="E8F2F3"/>
-                </a:solidFill>
-                <a:latin typeface="Arial"/>
-              </a:rPr>
-              <a:t>https://jasonnlim-listing-brochure-studio-jason-realty.static.hf.space — Generate, scroll, Edit brochure, Print/PDF</a:t>
-            </a:r>
-          </a:p>
-        </p:txBody>
-      </p:sp>
-    </p:spTree>
-  </p:cSld>
-  <p:clrMapOvr>
-    <a:masterClrMapping/>
-  </p:clrMapOvr>
-</p:sld>
-</file>
-
-<file path=ppt/slides/slide5.xml><?xml version="1.0" encoding="utf-8"?>
-<p:sld xmlns:a="http://schemas.openxmlformats.org/drawingml/2006/main" xmlns:p="http://schemas.openxmlformats.org/presentationml/2006/main" xmlns:r="http://schemas.openxmlformats.org/officeDocument/2006/relationships">
-  <p:cSld>
-    <p:spTree>
-      <p:nvGrpSpPr>
-        <p:cNvPr id="1" name=""/>
-        <p:cNvGrpSpPr/>
-        <p:nvPr/>
-      </p:nvGrpSpPr>
-      <p:grpSpPr/>
-      <p:sp>
-        <p:nvSpPr>
-          <p:cNvPr id="2" name="Rectangle 1"/>
-          <p:cNvSpPr/>
-          <p:nvPr/>
-        </p:nvSpPr>
-        <p:spPr>
-          <a:xfrm>
-            <a:off x="0" y="0"/>
-            <a:ext cx="12191695" cy="6858000"/>
-          </a:xfrm>
-          <a:prstGeom prst="rect">
-            <a:avLst/>
-          </a:prstGeom>
-          <a:solidFill>
-            <a:srgbClr val="FCFAF6"/>
-          </a:solidFill>
-          <a:ln>
-            <a:noFill/>
-          </a:ln>
-        </p:spPr>
-        <p:style>
-          <a:lnRef idx="1">
-            <a:schemeClr val="accent1"/>
-          </a:lnRef>
-          <a:fillRef idx="3">
-            <a:schemeClr val="accent1"/>
-          </a:fillRef>
-          <a:effectRef idx="2">
-            <a:schemeClr val="accent1"/>
-          </a:effectRef>
-          <a:fontRef idx="minor">
-            <a:schemeClr val="lt1"/>
-          </a:fontRef>
-        </p:style>
-        <p:txBody>
-          <a:bodyPr rtlCol="0" anchor="ctr"/>
-          <a:lstStyle/>
-          <a:p>
-            <a:pPr algn="ctr"/>
-          </a:p>
-        </p:txBody>
-      </p:sp>
-      <p:sp>
-        <p:nvSpPr>
-          <p:cNvPr id="3" name="Rectangle 2"/>
-          <p:cNvSpPr/>
-          <p:nvPr/>
-        </p:nvSpPr>
-        <p:spPr>
-          <a:xfrm>
-            <a:off x="0" y="0"/>
-            <a:ext cx="12191695" cy="91440"/>
-          </a:xfrm>
-          <a:prstGeom prst="rect">
-            <a:avLst/>
-          </a:prstGeom>
-          <a:solidFill>
-            <a:srgbClr val="1F6F78"/>
-          </a:solidFill>
-          <a:ln>
-            <a:noFill/>
-          </a:ln>
-        </p:spPr>
-        <p:style>
-          <a:lnRef idx="1">
-            <a:schemeClr val="accent1"/>
-          </a:lnRef>
-          <a:fillRef idx="3">
-            <a:schemeClr val="accent1"/>
-          </a:fillRef>
-          <a:effectRef idx="2">
-            <a:schemeClr val="accent1"/>
-          </a:effectRef>
-          <a:fontRef idx="minor">
-            <a:schemeClr val="lt1"/>
-          </a:fontRef>
-        </p:style>
-        <p:txBody>
-          <a:bodyPr rtlCol="0" anchor="ctr"/>
-          <a:lstStyle/>
-          <a:p>
-            <a:pPr algn="ctr"/>
-          </a:p>
-        </p:txBody>
-      </p:sp>
-      <p:sp>
-        <p:nvSpPr>
-          <p:cNvPr id="4" name="TextBox 3"/>
-          <p:cNvSpPr txBox="1"/>
-          <p:nvPr/>
-        </p:nvSpPr>
-        <p:spPr>
-          <a:xfrm>
-            <a:off x="640080" y="457200"/>
-            <a:ext cx="10515600" cy="365760"/>
-          </a:xfrm>
-          <a:prstGeom prst="rect">
-            <a:avLst/>
-          </a:prstGeom>
-          <a:noFill/>
-        </p:spPr>
-        <p:txBody>
-          <a:bodyPr wrap="square">
-            <a:spAutoFit/>
-          </a:bodyPr>
-          <a:lstStyle/>
-          <a:p>
-            <a:pPr algn="l"/>
-            <a:r>
-              <a:rPr sz="1200" b="1">
-                <a:solidFill>
-                  <a:srgbClr val="1F6F78"/>
-                </a:solidFill>
-                <a:latin typeface="Arial"/>
-              </a:rPr>
-              <a:t>ARCHITECTURE</a:t>
-            </a:r>
-          </a:p>
-        </p:txBody>
-      </p:sp>
-      <p:sp>
-        <p:nvSpPr>
-          <p:cNvPr id="5" name="TextBox 4"/>
-          <p:cNvSpPr txBox="1"/>
-          <p:nvPr/>
-        </p:nvSpPr>
-        <p:spPr>
-          <a:xfrm>
-            <a:off x="640080" y="1097280"/>
-            <a:ext cx="10515600" cy="1280160"/>
-          </a:xfrm>
-          <a:prstGeom prst="rect">
-            <a:avLst/>
-          </a:prstGeom>
-          <a:noFill/>
-        </p:spPr>
-        <p:txBody>
-          <a:bodyPr wrap="square">
-            <a:spAutoFit/>
-          </a:bodyPr>
-          <a:lstStyle/>
-          <a:p>
-            <a:pPr algn="l"/>
-            <a:r>
-              <a:rPr sz="2800" b="1">
-                <a:solidFill>
-                  <a:srgbClr val="0B1F33"/>
-                </a:solidFill>
-                <a:latin typeface="Arial"/>
-              </a:rPr>
-              <a:t>Built to ship. Built to observe.</a:t>
-            </a:r>
-          </a:p>
-        </p:txBody>
-      </p:sp>
-      <p:sp>
-        <p:nvSpPr>
-          <p:cNvPr id="6" name="TextBox 5"/>
-          <p:cNvSpPr txBox="1"/>
-          <p:nvPr/>
-        </p:nvSpPr>
-        <p:spPr>
-          <a:xfrm>
-            <a:off x="640080" y="2743200"/>
-            <a:ext cx="10515600" cy="2286000"/>
-          </a:xfrm>
-          <a:prstGeom prst="rect">
-            <a:avLst/>
-          </a:prstGeom>
-          <a:noFill/>
-        </p:spPr>
-        <p:txBody>
-          <a:bodyPr wrap="square">
-            <a:spAutoFit/>
-          </a:bodyPr>
-          <a:lstStyle/>
-          <a:p>
-            <a:pPr algn="l"/>
-            <a:r>
-              <a:rPr sz="1800" b="0">
-                <a:solidFill>
-                  <a:srgbClr val="5C6B7A"/>
-                </a:solidFill>
-                <a:latin typeface="Arial"/>
-              </a:rPr>
-              <a:t>React/Vite · Compass RapidAPI · Google Maps · Hugging Face static Space · Jason Lim brand</a:t>
-            </a:r>
-          </a:p>
-        </p:txBody>
-      </p:sp>
-    </p:spTree>
-  </p:cSld>
-  <p:clrMapOvr>
-    <a:masterClrMapping/>
-  </p:clrMapOvr>
-</p:sld>
-</file>
-
-<file path=ppt/slides/slide6.xml><?xml version="1.0" encoding="utf-8"?>
-<p:sld xmlns:a="http://schemas.openxmlformats.org/drawingml/2006/main" xmlns:p="http://schemas.openxmlformats.org/presentationml/2006/main" xmlns:r="http://schemas.openxmlformats.org/officeDocument/2006/relationships">
-  <p:cSld>
-    <p:spTree>
-      <p:nvGrpSpPr>
-        <p:cNvPr id="1" name=""/>
-        <p:cNvGrpSpPr/>
-        <p:nvPr/>
-      </p:nvGrpSpPr>
-      <p:grpSpPr/>
-      <p:sp>
-        <p:nvSpPr>
-          <p:cNvPr id="2" name="Rectangle 1"/>
-          <p:cNvSpPr/>
-          <p:nvPr/>
-        </p:nvSpPr>
-        <p:spPr>
-          <a:xfrm>
-            <a:off x="0" y="0"/>
-            <a:ext cx="12191695" cy="6858000"/>
-          </a:xfrm>
-          <a:prstGeom prst="rect">
-            <a:avLst/>
-          </a:prstGeom>
-          <a:solidFill>
-            <a:srgbClr val="FCFAF6"/>
-          </a:solidFill>
-          <a:ln>
-            <a:noFill/>
-          </a:ln>
-        </p:spPr>
-        <p:style>
-          <a:lnRef idx="1">
-            <a:schemeClr val="accent1"/>
-          </a:lnRef>
-          <a:fillRef idx="3">
-            <a:schemeClr val="accent1"/>
-          </a:fillRef>
-          <a:effectRef idx="2">
-            <a:schemeClr val="accent1"/>
-          </a:effectRef>
-          <a:fontRef idx="minor">
-            <a:schemeClr val="lt1"/>
-          </a:fontRef>
-        </p:style>
-        <p:txBody>
-          <a:bodyPr rtlCol="0" anchor="ctr"/>
-          <a:lstStyle/>
-          <a:p>
-            <a:pPr algn="ctr"/>
-          </a:p>
-        </p:txBody>
-      </p:sp>
-      <p:sp>
-        <p:nvSpPr>
-          <p:cNvPr id="3" name="Rectangle 2"/>
-          <p:cNvSpPr/>
-          <p:nvPr/>
-        </p:nvSpPr>
-        <p:spPr>
-          <a:xfrm>
-            <a:off x="0" y="0"/>
-            <a:ext cx="12191695" cy="91440"/>
-          </a:xfrm>
-          <a:prstGeom prst="rect">
-            <a:avLst/>
-          </a:prstGeom>
-          <a:solidFill>
-            <a:srgbClr val="1F6F78"/>
-          </a:solidFill>
-          <a:ln>
-            <a:noFill/>
-          </a:ln>
-        </p:spPr>
-        <p:style>
-          <a:lnRef idx="1">
-            <a:schemeClr val="accent1"/>
-          </a:lnRef>
-          <a:fillRef idx="3">
-            <a:schemeClr val="accent1"/>
-          </a:fillRef>
-          <a:effectRef idx="2">
-            <a:schemeClr val="accent1"/>
-          </a:effectRef>
-          <a:fontRef idx="minor">
-            <a:schemeClr val="lt1"/>
-          </a:fontRef>
-        </p:style>
-        <p:txBody>
-          <a:bodyPr rtlCol="0" anchor="ctr"/>
-          <a:lstStyle/>
-          <a:p>
-            <a:pPr algn="ctr"/>
-          </a:p>
-        </p:txBody>
-      </p:sp>
-      <p:sp>
-        <p:nvSpPr>
-          <p:cNvPr id="4" name="TextBox 3"/>
-          <p:cNvSpPr txBox="1"/>
-          <p:nvPr/>
-        </p:nvSpPr>
-        <p:spPr>
-          <a:xfrm>
-            <a:off x="640080" y="457200"/>
-            <a:ext cx="10515600" cy="365760"/>
-          </a:xfrm>
-          <a:prstGeom prst="rect">
-            <a:avLst/>
-          </a:prstGeom>
-          <a:noFill/>
-        </p:spPr>
-        <p:txBody>
-          <a:bodyPr wrap="square">
-            <a:spAutoFit/>
-          </a:bodyPr>
-          <a:lstStyle/>
-          <a:p>
-            <a:pPr algn="l"/>
-            <a:r>
-              <a:rPr sz="1200" b="1">
-                <a:solidFill>
-                  <a:srgbClr val="1F6F78"/>
-                </a:solidFill>
-                <a:latin typeface="Arial"/>
-              </a:rPr>
-              <a:t>LANGSMITH TRAJECTORY</a:t>
-            </a:r>
-          </a:p>
-        </p:txBody>
-      </p:sp>
-      <p:sp>
-        <p:nvSpPr>
-          <p:cNvPr id="5" name="TextBox 4"/>
-          <p:cNvSpPr txBox="1"/>
-          <p:nvPr/>
-        </p:nvSpPr>
-        <p:spPr>
-          <a:xfrm>
-            <a:off x="640080" y="1097280"/>
-            <a:ext cx="10515600" cy="1280160"/>
-          </a:xfrm>
-          <a:prstGeom prst="rect">
-            <a:avLst/>
-          </a:prstGeom>
-          <a:noFill/>
-        </p:spPr>
-        <p:txBody>
-          <a:bodyPr wrap="square">
-            <a:spAutoFit/>
-          </a:bodyPr>
-          <a:lstStyle/>
-          <a:p>
-            <a:pPr algn="l"/>
-            <a:r>
-              <a:rPr sz="2800" b="1">
-                <a:solidFill>
-                  <a:srgbClr val="0B1F33"/>
-                </a:solidFill>
-                <a:latin typeface="Arial"/>
-              </a:rPr>
-              <a:t>Every brochure run is a trajectory you can debug.</a:t>
-            </a:r>
-          </a:p>
-        </p:txBody>
-      </p:sp>
-      <p:sp>
-        <p:nvSpPr>
-          <p:cNvPr id="6" name="TextBox 5"/>
-          <p:cNvSpPr txBox="1"/>
-          <p:nvPr/>
-        </p:nvSpPr>
-        <p:spPr>
-          <a:xfrm>
-            <a:off x="640080" y="2743200"/>
-            <a:ext cx="10515600" cy="2286000"/>
-          </a:xfrm>
-          <a:prstGeom prst="rect">
-            <a:avLst/>
-          </a:prstGeom>
-          <a:noFill/>
-        </p:spPr>
-        <p:txBody>
-          <a:bodyPr wrap="square">
-            <a:spAutoFit/>
-          </a:bodyPr>
-          <a:lstStyle/>
-          <a:p>
-            <a:pPr algn="l"/>
-            <a:r>
-              <a:rPr sz="1800" b="0">
-                <a:solidFill>
-                  <a:srgbClr val="5C6B7A"/>
-                </a:solidFill>
-                <a:latin typeface="Arial"/>
-              </a:rPr>
-              <a:t>Intake → Scrape → Extract → Compose → Human edit → Export. Trace failures, compare runs, build evals.</a:t>
-            </a:r>
-          </a:p>
-        </p:txBody>
-      </p:sp>
-    </p:spTree>
-  </p:cSld>
-  <p:clrMapOvr>
-    <a:masterClrMapping/>
-  </p:clrMapOvr>
-</p:sld>
-</file>
-
-<file path=ppt/slides/slide7.xml><?xml version="1.0" encoding="utf-8"?>
-<p:sld xmlns:a="http://schemas.openxmlformats.org/drawingml/2006/main" xmlns:p="http://schemas.openxmlformats.org/presentationml/2006/main" xmlns:r="http://schemas.openxmlformats.org/officeDocument/2006/relationships">
-  <p:cSld>
-    <p:spTree>
-      <p:nvGrpSpPr>
-        <p:cNvPr id="1" name=""/>
-        <p:cNvGrpSpPr/>
-        <p:nvPr/>
-      </p:nvGrpSpPr>
-      <p:grpSpPr/>
-      <p:sp>
-        <p:nvSpPr>
-          <p:cNvPr id="2" name="Rectangle 1"/>
-          <p:cNvSpPr/>
-          <p:nvPr/>
-        </p:nvSpPr>
-        <p:spPr>
-          <a:xfrm>
-            <a:off x="0" y="0"/>
-            <a:ext cx="12191695" cy="6858000"/>
-          </a:xfrm>
-          <a:prstGeom prst="rect">
-            <a:avLst/>
-          </a:prstGeom>
-          <a:solidFill>
-            <a:srgbClr val="FCFAF6"/>
-          </a:solidFill>
-          <a:ln>
-            <a:noFill/>
-          </a:ln>
-        </p:spPr>
-        <p:style>
-          <a:lnRef idx="1">
-            <a:schemeClr val="accent1"/>
-          </a:lnRef>
-          <a:fillRef idx="3">
-            <a:schemeClr val="accent1"/>
-          </a:fillRef>
-          <a:effectRef idx="2">
-            <a:schemeClr val="accent1"/>
-          </a:effectRef>
-          <a:fontRef idx="minor">
-            <a:schemeClr val="lt1"/>
-          </a:fontRef>
-        </p:style>
-        <p:txBody>
-          <a:bodyPr rtlCol="0" anchor="ctr"/>
-          <a:lstStyle/>
-          <a:p>
-            <a:pPr algn="ctr"/>
-          </a:p>
-        </p:txBody>
-      </p:sp>
-      <p:sp>
-        <p:nvSpPr>
-          <p:cNvPr id="3" name="Rectangle 2"/>
-          <p:cNvSpPr/>
-          <p:nvPr/>
-        </p:nvSpPr>
-        <p:spPr>
-          <a:xfrm>
-            <a:off x="0" y="0"/>
-            <a:ext cx="12191695" cy="91440"/>
-          </a:xfrm>
-          <a:prstGeom prst="rect">
-            <a:avLst/>
-          </a:prstGeom>
-          <a:solidFill>
-            <a:srgbClr val="1F6F78"/>
-          </a:solidFill>
-          <a:ln>
-            <a:noFill/>
-          </a:ln>
-        </p:spPr>
-        <p:style>
-          <a:lnRef idx="1">
-            <a:schemeClr val="accent1"/>
-          </a:lnRef>
-          <a:fillRef idx="3">
-            <a:schemeClr val="accent1"/>
-          </a:fillRef>
-          <a:effectRef idx="2">
-            <a:schemeClr val="accent1"/>
-          </a:effectRef>
-          <a:fontRef idx="minor">
-            <a:schemeClr val="lt1"/>
-          </a:fontRef>
-        </p:style>
-        <p:txBody>
-          <a:bodyPr rtlCol="0" anchor="ctr"/>
-          <a:lstStyle/>
-          <a:p>
-            <a:pPr algn="ctr"/>
-          </a:p>
-        </p:txBody>
-      </p:sp>
-      <p:sp>
-        <p:nvSpPr>
-          <p:cNvPr id="4" name="TextBox 3"/>
-          <p:cNvSpPr txBox="1"/>
-          <p:nvPr/>
-        </p:nvSpPr>
-        <p:spPr>
-          <a:xfrm>
-            <a:off x="640080" y="457200"/>
-            <a:ext cx="10515600" cy="365760"/>
-          </a:xfrm>
-          <a:prstGeom prst="rect">
-            <a:avLst/>
-          </a:prstGeom>
-          <a:noFill/>
-        </p:spPr>
-        <p:txBody>
-          <a:bodyPr wrap="square">
-            <a:spAutoFit/>
-          </a:bodyPr>
-          <a:lstStyle/>
-          <a:p>
-            <a:pPr algn="l"/>
-            <a:r>
-              <a:rPr sz="1200" b="1">
-                <a:solidFill>
-                  <a:srgbClr val="1F6F78"/>
-                </a:solidFill>
-                <a:latin typeface="Arial"/>
-              </a:rPr>
-              <a:t>WHY THIS WINS</a:t>
-            </a:r>
-          </a:p>
-        </p:txBody>
-      </p:sp>
-      <p:sp>
-        <p:nvSpPr>
-          <p:cNvPr id="5" name="TextBox 4"/>
-          <p:cNvSpPr txBox="1"/>
-          <p:nvPr/>
-        </p:nvSpPr>
-        <p:spPr>
-          <a:xfrm>
-            <a:off x="640080" y="1097280"/>
-            <a:ext cx="10515600" cy="1280160"/>
-          </a:xfrm>
-          <a:prstGeom prst="rect">
-            <a:avLst/>
-          </a:prstGeom>
-          <a:noFill/>
-        </p:spPr>
-        <p:txBody>
-          <a:bodyPr wrap="square">
-            <a:spAutoFit/>
-          </a:bodyPr>
-          <a:lstStyle/>
-          <a:p>
-            <a:pPr algn="l"/>
-            <a:r>
-              <a:rPr sz="2800" b="1">
-                <a:solidFill>
-                  <a:srgbClr val="0B1F33"/>
-                </a:solidFill>
-                <a:latin typeface="Arial"/>
-              </a:rPr>
-              <a:t>Real estate x AI — owned by someone in the deal.</a:t>
-            </a:r>
-          </a:p>
-        </p:txBody>
-      </p:sp>
-      <p:sp>
-        <p:nvSpPr>
-          <p:cNvPr id="6" name="TextBox 5"/>
-          <p:cNvSpPr txBox="1"/>
-          <p:nvPr/>
-        </p:nvSpPr>
-        <p:spPr>
-          <a:xfrm>
-            <a:off x="640080" y="2743200"/>
-            <a:ext cx="10515600" cy="2286000"/>
-          </a:xfrm>
-          <a:prstGeom prst="rect">
-            <a:avLst/>
-          </a:prstGeom>
-          <a:noFill/>
-        </p:spPr>
-        <p:txBody>
-          <a:bodyPr wrap="square">
-            <a:spAutoFit/>
-          </a:bodyPr>
-          <a:lstStyle/>
-          <a:p>
-            <a:pPr algn="l"/>
-            <a:r>
-              <a:rPr sz="1800" b="0">
-                <a:solidFill>
-                  <a:srgbClr val="5C6B7A"/>
-                </a:solidFill>
-                <a:latin typeface="Arial"/>
-              </a:rPr>
-              <a:t>Distribution at listing appointments. Workflow wedge. Licensed agent trust. HF + LangSmith instrumentation.</a:t>
-            </a:r>
-          </a:p>
-        </p:txBody>
-      </p:sp>
-    </p:spTree>
-  </p:cSld>
-  <p:clrMapOvr>
-    <a:masterClrMapping/>
-  </p:clrMapOvr>
-</p:sld>
-</file>
-
-<file path=ppt/slides/slide8.xml><?xml version="1.0" encoding="utf-8"?>
-<p:sld xmlns:a="http://schemas.openxmlformats.org/drawingml/2006/main" xmlns:p="http://schemas.openxmlformats.org/presentationml/2006/main" xmlns:r="http://schemas.openxmlformats.org/officeDocument/2006/relationships">
-  <p:cSld>
-    <p:spTree>
-      <p:nvGrpSpPr>
-        <p:cNvPr id="1" name=""/>
-        <p:cNvGrpSpPr/>
-        <p:nvPr/>
-      </p:nvGrpSpPr>
-      <p:grpSpPr/>
-      <p:sp>
-        <p:nvSpPr>
-          <p:cNvPr id="2" name="Rectangle 1"/>
-          <p:cNvSpPr/>
-          <p:nvPr/>
-        </p:nvSpPr>
-        <p:spPr>
-          <a:xfrm>
-            <a:off x="0" y="0"/>
-            <a:ext cx="12191695" cy="6858000"/>
-          </a:xfrm>
-          <a:prstGeom prst="rect">
-            <a:avLst/>
-          </a:prstGeom>
-          <a:solidFill>
-            <a:srgbClr val="FCFAF6"/>
-          </a:solidFill>
-          <a:ln>
-            <a:noFill/>
-          </a:ln>
-        </p:spPr>
-        <p:style>
-          <a:lnRef idx="1">
-            <a:schemeClr val="accent1"/>
-          </a:lnRef>
-          <a:fillRef idx="3">
-            <a:schemeClr val="accent1"/>
-          </a:fillRef>
-          <a:effectRef idx="2">
-            <a:schemeClr val="accent1"/>
-          </a:effectRef>
-          <a:fontRef idx="minor">
-            <a:schemeClr val="lt1"/>
-          </a:fontRef>
-        </p:style>
-        <p:txBody>
-          <a:bodyPr rtlCol="0" anchor="ctr"/>
-          <a:lstStyle/>
-          <a:p>
-            <a:pPr algn="ctr"/>
-          </a:p>
-        </p:txBody>
-      </p:sp>
-      <p:sp>
-        <p:nvSpPr>
-          <p:cNvPr id="3" name="Rectangle 2"/>
-          <p:cNvSpPr/>
-          <p:nvPr/>
-        </p:nvSpPr>
-        <p:spPr>
-          <a:xfrm>
-            <a:off x="0" y="0"/>
-            <a:ext cx="12191695" cy="91440"/>
-          </a:xfrm>
-          <a:prstGeom prst="rect">
-            <a:avLst/>
-          </a:prstGeom>
-          <a:solidFill>
-            <a:srgbClr val="1F6F78"/>
-          </a:solidFill>
-          <a:ln>
-            <a:noFill/>
-          </a:ln>
-        </p:spPr>
-        <p:style>
-          <a:lnRef idx="1">
-            <a:schemeClr val="accent1"/>
-          </a:lnRef>
-          <a:fillRef idx="3">
-            <a:schemeClr val="accent1"/>
-          </a:fillRef>
-          <a:effectRef idx="2">
-            <a:schemeClr val="accent1"/>
-          </a:effectRef>
-          <a:fontRef idx="minor">
-            <a:schemeClr val="lt1"/>
-          </a:fontRef>
-        </p:style>
-        <p:txBody>
-          <a:bodyPr rtlCol="0" anchor="ctr"/>
-          <a:lstStyle/>
-          <a:p>
-            <a:pPr algn="ctr"/>
-          </a:p>
-        </p:txBody>
-      </p:sp>
-      <p:sp>
-        <p:nvSpPr>
-          <p:cNvPr id="4" name="TextBox 3"/>
-          <p:cNvSpPr txBox="1"/>
-          <p:nvPr/>
-        </p:nvSpPr>
-        <p:spPr>
-          <a:xfrm>
-            <a:off x="640080" y="457200"/>
-            <a:ext cx="10515600" cy="365760"/>
-          </a:xfrm>
-          <a:prstGeom prst="rect">
-            <a:avLst/>
-          </a:prstGeom>
-          <a:noFill/>
-        </p:spPr>
-        <p:txBody>
-          <a:bodyPr wrap="square">
-            <a:spAutoFit/>
-          </a:bodyPr>
-          <a:lstStyle/>
-          <a:p>
-            <a:pPr algn="l"/>
-            <a:r>
-              <a:rPr sz="1200" b="1">
-                <a:solidFill>
-                  <a:srgbClr val="1F6F78"/>
-                </a:solidFill>
-                <a:latin typeface="Arial"/>
-              </a:rPr>
-              <a:t>HOW TO EXPAND</a:t>
-            </a:r>
-          </a:p>
-        </p:txBody>
-      </p:sp>
-      <p:sp>
-        <p:nvSpPr>
-          <p:cNvPr id="5" name="TextBox 4"/>
-          <p:cNvSpPr txBox="1"/>
-          <p:nvPr/>
-        </p:nvSpPr>
-        <p:spPr>
-          <a:xfrm>
-            <a:off x="640080" y="1097280"/>
-            <a:ext cx="10515600" cy="1280160"/>
-          </a:xfrm>
-          <a:prstGeom prst="rect">
-            <a:avLst/>
-          </a:prstGeom>
-          <a:noFill/>
-        </p:spPr>
-        <p:txBody>
-          <a:bodyPr wrap="square">
-            <a:spAutoFit/>
-          </a:bodyPr>
-          <a:lstStyle/>
-          <a:p>
-            <a:pPr algn="l"/>
-            <a:r>
-              <a:rPr sz="2800" b="1">
-                <a:solidFill>
-                  <a:srgbClr val="0B1F33"/>
-                </a:solidFill>
-                <a:latin typeface="Arial"/>
-              </a:rPr>
-              <a:t>From brochure MVP to listing OS.</a:t>
-            </a:r>
-          </a:p>
-        </p:txBody>
-      </p:sp>
-      <p:sp>
-        <p:nvSpPr>
-          <p:cNvPr id="6" name="TextBox 5"/>
-          <p:cNvSpPr txBox="1"/>
-          <p:nvPr/>
-        </p:nvSpPr>
-        <p:spPr>
-          <a:xfrm>
-            <a:off x="640080" y="2743200"/>
-            <a:ext cx="10515600" cy="2286000"/>
-          </a:xfrm>
-          <a:prstGeom prst="rect">
-            <a:avLst/>
-          </a:prstGeom>
-          <a:noFill/>
-        </p:spPr>
-        <p:txBody>
-          <a:bodyPr wrap="square">
-            <a:spAutoFit/>
-          </a:bodyPr>
-          <a:lstStyle/>
-          <a:p>
-            <a:pPr algn="l"/>
-            <a:r>
-              <a:rPr sz="1800" b="0">
-                <a:solidFill>
-                  <a:srgbClr val="5C6B7A"/>
-                </a:solidFill>
-                <a:latin typeface="Arial"/>
-              </a:rPr>
-              <a:t>Near-term: LangGraph + LangSmith + LLM polish. Product: AI Estimate + seller portal. Scale: APIs + mobile packs.</a:t>
-            </a:r>
-          </a:p>
-        </p:txBody>
-      </p:sp>
-    </p:spTree>
-  </p:cSld>
-  <p:clrMapOvr>
-    <a:masterClrMapping/>
-  </p:clrMapOvr>
-</p:sld>
-</file>
-
-<file path=ppt/slides/slide9.xml><?xml version="1.0" encoding="utf-8"?>
-<p:sld xmlns:a="http://schemas.openxmlformats.org/drawingml/2006/main" xmlns:p="http://schemas.openxmlformats.org/presentationml/2006/main" xmlns:r="http://schemas.openxmlformats.org/officeDocument/2006/relationships">
-  <p:cSld>
-    <p:spTree>
-      <p:nvGrpSpPr>
-        <p:cNvPr id="1" name=""/>
-        <p:cNvGrpSpPr/>
-        <p:nvPr/>
-      </p:nvGrpSpPr>
-      <p:grpSpPr/>
-      <p:sp>
-        <p:nvSpPr>
-          <p:cNvPr id="2" name="Rectangle 1"/>
-          <p:cNvSpPr/>
-          <p:nvPr/>
-        </p:nvSpPr>
-        <p:spPr>
-          <a:xfrm>
-            <a:off x="0" y="0"/>
-            <a:ext cx="12191695" cy="6858000"/>
-          </a:xfrm>
-          <a:prstGeom prst="rect">
-            <a:avLst/>
-          </a:prstGeom>
-          <a:solidFill>
-            <a:srgbClr val="FCFAF6"/>
-          </a:solidFill>
-          <a:ln>
-            <a:noFill/>
-          </a:ln>
-        </p:spPr>
-        <p:style>
-          <a:lnRef idx="1">
-            <a:schemeClr val="accent1"/>
-          </a:lnRef>
-          <a:fillRef idx="3">
-            <a:schemeClr val="accent1"/>
-          </a:fillRef>
-          <a:effectRef idx="2">
-            <a:schemeClr val="accent1"/>
-          </a:effectRef>
-          <a:fontRef idx="minor">
-            <a:schemeClr val="lt1"/>
-          </a:fontRef>
-        </p:style>
-        <p:txBody>
-          <a:bodyPr rtlCol="0" anchor="ctr"/>
-          <a:lstStyle/>
-          <a:p>
-            <a:pPr algn="ctr"/>
-          </a:p>
-        </p:txBody>
-      </p:sp>
-      <p:sp>
-        <p:nvSpPr>
-          <p:cNvPr id="3" name="Rectangle 2"/>
-          <p:cNvSpPr/>
-          <p:nvPr/>
-        </p:nvSpPr>
-        <p:spPr>
-          <a:xfrm>
-            <a:off x="0" y="0"/>
-            <a:ext cx="12191695" cy="91440"/>
-          </a:xfrm>
-          <a:prstGeom prst="rect">
-            <a:avLst/>
-          </a:prstGeom>
-          <a:solidFill>
-            <a:srgbClr val="1F6F78"/>
-          </a:solidFill>
-          <a:ln>
-            <a:noFill/>
-          </a:ln>
-        </p:spPr>
-        <p:style>
-          <a:lnRef idx="1">
-            <a:schemeClr val="accent1"/>
-          </a:lnRef>
-          <a:fillRef idx="3">
-            <a:schemeClr val="accent1"/>
-          </a:fillRef>
-          <a:effectRef idx="2">
-            <a:schemeClr val="accent1"/>
-          </a:effectRef>
-          <a:fontRef idx="minor">
-            <a:schemeClr val="lt1"/>
-          </a:fontRef>
-        </p:style>
-        <p:txBody>
-          <a:bodyPr rtlCol="0" anchor="ctr"/>
-          <a:lstStyle/>
-          <a:p>
-            <a:pPr algn="ctr"/>
-          </a:p>
-        </p:txBody>
-      </p:sp>
-      <p:sp>
-        <p:nvSpPr>
-          <p:cNvPr id="4" name="TextBox 3"/>
-          <p:cNvSpPr txBox="1"/>
-          <p:nvPr/>
-        </p:nvSpPr>
-        <p:spPr>
-          <a:xfrm>
-            <a:off x="640080" y="457200"/>
-            <a:ext cx="10515600" cy="365760"/>
-          </a:xfrm>
-          <a:prstGeom prst="rect">
-            <a:avLst/>
-          </a:prstGeom>
-          <a:noFill/>
-        </p:spPr>
-        <p:txBody>
-          <a:bodyPr wrap="square">
-            <a:spAutoFit/>
-          </a:bodyPr>
-          <a:lstStyle/>
-          <a:p>
-            <a:pPr algn="l"/>
-            <a:r>
-              <a:rPr sz="1200" b="1">
-                <a:solidFill>
-                  <a:srgbClr val="1F6F78"/>
-                </a:solidFill>
-                <a:latin typeface="Arial"/>
-              </a:rPr>
-              <a:t>WHAT IS LIVE TODAY</a:t>
-            </a:r>
-          </a:p>
-        </p:txBody>
-      </p:sp>
-      <p:sp>
-        <p:nvSpPr>
-          <p:cNvPr id="5" name="TextBox 4"/>
-          <p:cNvSpPr txBox="1"/>
-          <p:nvPr/>
-        </p:nvSpPr>
-        <p:spPr>
-          <a:xfrm>
-            <a:off x="640080" y="1097280"/>
-            <a:ext cx="10515600" cy="1280160"/>
-          </a:xfrm>
-          <a:prstGeom prst="rect">
-            <a:avLst/>
-          </a:prstGeom>
-          <a:noFill/>
-        </p:spPr>
-        <p:txBody>
-          <a:bodyPr wrap="square">
-            <a:spAutoFit/>
-          </a:bodyPr>
-          <a:lstStyle/>
-          <a:p>
-            <a:pPr algn="l"/>
-            <a:r>
-              <a:rPr sz="2800" b="1">
-                <a:solidFill>
-                  <a:srgbClr val="0B1F33"/>
-                </a:solidFill>
-                <a:latin typeface="Arial"/>
-              </a:rPr>
-              <a:t>Shipped. Not slideware.</a:t>
-            </a:r>
-          </a:p>
-        </p:txBody>
-      </p:sp>
-      <p:sp>
-        <p:nvSpPr>
-          <p:cNvPr id="6" name="TextBox 5"/>
-          <p:cNvSpPr txBox="1"/>
-          <p:nvPr/>
-        </p:nvSpPr>
-        <p:spPr>
-          <a:xfrm>
-            <a:off x="640080" y="2743200"/>
-            <a:ext cx="10515600" cy="2286000"/>
-          </a:xfrm>
-          <a:prstGeom prst="rect">
-            <a:avLst/>
-          </a:prstGeom>
-          <a:noFill/>
-        </p:spPr>
-        <p:txBody>
-          <a:bodyPr wrap="square">
-            <a:spAutoFit/>
-          </a:bodyPr>
-          <a:lstStyle/>
-          <a:p>
-            <a:pPr algn="l"/>
-            <a:r>
-              <a:rPr sz="1800" b="0">
-                <a:solidFill>
-                  <a:srgbClr val="5C6B7A"/>
-                </a:solidFill>
-                <a:latin typeface="Arial"/>
-              </a:rPr>
-              <a:t>HF Space live. Compass-only RapidAPI (honest). Example photos fallback. Next: LangSmith traces.</a:t>
+              <a:t>Jason Lim · Compass · DRE #02444964 · jason.lim@compass.com · (510) 480-7191 · jasonlimrealty.com — Questions? Open the Hugging Face Space live.</a:t>
             </a:r>
           </a:p>
         </p:txBody>

</xml_diff>

<commit_message>
Enrich 4-slide pitch: before/after hook + expand architecture
Hook contrasts Word/Canva rebuild vs URL→template→edit. Why/expand
adds Observe→Analyze→Generate→Distribute roadmap and pipeline;
LangSmith stays as debug/analysis expansion only.

Co-authored-by: Jason N. Lim <jhhlim@users.noreply.github.com>
</commit_message>
<xml_diff>
--- a/Jason_Lim_Project_Notes_Demo_10min_VC_Pitch.pptx
+++ b/Jason_Lim_Project_Notes_Demo_10min_VC_Pitch.pptx
@@ -3143,7 +3143,7 @@
         <p:spPr>
           <a:xfrm>
             <a:off x="0" y="0"/>
-            <a:ext cx="137160" cy="6858000"/>
+            <a:ext cx="128016" cy="6858000"/>
           </a:xfrm>
           <a:prstGeom prst="rect">
             <a:avLst/>
@@ -3185,8 +3185,8 @@
         </p:nvSpPr>
         <p:spPr>
           <a:xfrm>
-            <a:off x="640080" y="1280160"/>
-            <a:ext cx="10515600" cy="365760"/>
+            <a:off x="594360" y="822960"/>
+            <a:ext cx="10789920" cy="320040"/>
           </a:xfrm>
           <a:prstGeom prst="rect">
             <a:avLst/>
@@ -3199,14 +3199,19 @@
           </a:bodyPr>
           <a:lstStyle/>
           <a:p>
-            <a:r>
-              <a:rPr sz="1200" b="1">
+            <a:pPr>
+              <a:spcAft>
+                <a:spcPts val="600"/>
+              </a:spcAft>
+            </a:pPr>
+            <a:r>
+              <a:rPr sz="1100" b="1">
                 <a:solidFill>
                   <a:srgbClr val="B08D57"/>
                 </a:solidFill>
                 <a:latin typeface="Arial"/>
               </a:rPr>
-              <a:t>PROJECT NOTES DEMO · ~10 MIN</a:t>
+              <a:t>HOOK — BEFORE vs AFTER</a:t>
             </a:r>
           </a:p>
         </p:txBody>
@@ -3219,8 +3224,8 @@
         </p:nvSpPr>
         <p:spPr>
           <a:xfrm>
-            <a:off x="640080" y="1920240"/>
-            <a:ext cx="10515600" cy="1463040"/>
+            <a:off x="594360" y="1280160"/>
+            <a:ext cx="10789920" cy="1188720"/>
           </a:xfrm>
           <a:prstGeom prst="rect">
             <a:avLst/>
@@ -3233,14 +3238,19 @@
           </a:bodyPr>
           <a:lstStyle/>
           <a:p>
-            <a:r>
-              <a:rPr sz="3000" b="1">
+            <a:pPr>
+              <a:spcAft>
+                <a:spcPts val="600"/>
+              </a:spcAft>
+            </a:pPr>
+            <a:r>
+              <a:rPr sz="2600" b="1">
                 <a:solidFill>
                   <a:srgbClr val="FFFFFF"/>
                 </a:solidFill>
                 <a:latin typeface="Arial"/>
               </a:rPr>
-              <a:t>Luxury listing brochures — from a Compass URL, in seconds.</a:t>
+              <a:t>From Canva chaos → Compass URL → luxury brochure.</a:t>
             </a:r>
           </a:p>
         </p:txBody>
@@ -3253,8 +3263,8 @@
         </p:nvSpPr>
         <p:spPr>
           <a:xfrm>
-            <a:off x="640080" y="3840480"/>
-            <a:ext cx="10515600" cy="1828800"/>
+            <a:off x="594360" y="2743200"/>
+            <a:ext cx="10789920" cy="3200400"/>
           </a:xfrm>
           <a:prstGeom prst="rect">
             <a:avLst/>
@@ -3267,14 +3277,51 @@
           </a:bodyPr>
           <a:lstStyle/>
           <a:p>
-            <a:r>
-              <a:rPr sz="1600" b="0">
+            <a:pPr>
+              <a:spcAft>
+                <a:spcPts val="600"/>
+              </a:spcAft>
+            </a:pPr>
+            <a:r>
+              <a:rPr sz="1500" b="0">
                 <a:solidFill>
                   <a:srgbClr val="E8F2F3"/>
                 </a:solidFill>
                 <a:latin typeface="Arial"/>
               </a:rPr>
-              <a:t>Pain: hours in Canva. Product: live HF Space (Compass RapidAPI → brochure → Edit → PDF). Builder: Jason Lim, Compass DRE #02444964.</a:t>
+              <a:t>BEFORE (Word/Canva): hunt photos, paste facts, fight templates, rebuild every listing for hours.</a:t>
+            </a:r>
+          </a:p>
+          <a:p>
+            <a:pPr>
+              <a:spcAft>
+                <a:spcPts val="600"/>
+              </a:spcAft>
+            </a:pPr>
+            <a:r>
+              <a:rPr sz="1500" b="0">
+                <a:solidFill>
+                  <a:srgbClr val="E8F2F3"/>
+                </a:solidFill>
+                <a:latin typeface="Arial"/>
+              </a:rPr>
+              <a:t>AFTER (HF Space): paste Compass URL → auto-fill branded template with photos/facts → Edit brochure → Print/PDF.</a:t>
+            </a:r>
+          </a:p>
+          <a:p>
+            <a:pPr>
+              <a:spcAft>
+                <a:spcPts val="600"/>
+              </a:spcAft>
+            </a:pPr>
+            <a:r>
+              <a:rPr sz="1500" b="0">
+                <a:solidFill>
+                  <a:srgbClr val="E8F2F3"/>
+                </a:solidFill>
+                <a:latin typeface="Arial"/>
+              </a:rPr>
+              <a:t>Stop designing from a blank page — input a URL, then edit. Jason Lim · Compass · DRE #02444964</a:t>
             </a:r>
           </a:p>
         </p:txBody>
@@ -3349,7 +3396,7 @@
         <p:spPr>
           <a:xfrm>
             <a:off x="0" y="0"/>
-            <a:ext cx="12191695" cy="91440"/>
+            <a:ext cx="12191695" cy="82296"/>
           </a:xfrm>
           <a:prstGeom prst="rect">
             <a:avLst/>
@@ -3391,8 +3438,8 @@
         </p:nvSpPr>
         <p:spPr>
           <a:xfrm>
-            <a:off x="640080" y="457200"/>
-            <a:ext cx="10515600" cy="365760"/>
+            <a:off x="594360" y="365760"/>
+            <a:ext cx="10789920" cy="320040"/>
           </a:xfrm>
           <a:prstGeom prst="rect">
             <a:avLst/>
@@ -3405,8 +3452,13 @@
           </a:bodyPr>
           <a:lstStyle/>
           <a:p>
-            <a:r>
-              <a:rPr sz="1200" b="1">
+            <a:pPr>
+              <a:spcAft>
+                <a:spcPts val="600"/>
+              </a:spcAft>
+            </a:pPr>
+            <a:r>
+              <a:rPr sz="1100" b="1">
                 <a:solidFill>
                   <a:srgbClr val="1F6F78"/>
                 </a:solidFill>
@@ -3425,8 +3477,8 @@
         </p:nvSpPr>
         <p:spPr>
           <a:xfrm>
-            <a:off x="640080" y="1097280"/>
-            <a:ext cx="10515600" cy="1280160"/>
+            <a:off x="594360" y="868680"/>
+            <a:ext cx="10789920" cy="1097280"/>
           </a:xfrm>
           <a:prstGeom prst="rect">
             <a:avLst/>
@@ -3439,14 +3491,19 @@
           </a:bodyPr>
           <a:lstStyle/>
           <a:p>
-            <a:r>
-              <a:rPr sz="2800" b="1">
+            <a:pPr>
+              <a:spcAft>
+                <a:spcPts val="600"/>
+              </a:spcAft>
+            </a:pPr>
+            <a:r>
+              <a:rPr sz="2400" b="1">
                 <a:solidFill>
                   <a:srgbClr val="0B1F33"/>
                 </a:solidFill>
                 <a:latin typeface="Arial"/>
               </a:rPr>
-              <a:t>Screen-share the Space. This is the pitch.</a:t>
+              <a:t>Screen-share: URL in → brochure out.</a:t>
             </a:r>
           </a:p>
         </p:txBody>
@@ -3459,8 +3516,8 @@
         </p:nvSpPr>
         <p:spPr>
           <a:xfrm>
-            <a:off x="640080" y="2743200"/>
-            <a:ext cx="10515600" cy="2926080"/>
+            <a:off x="594360" y="2194560"/>
+            <a:ext cx="10789920" cy="3840480"/>
           </a:xfrm>
           <a:prstGeom prst="rect">
             <a:avLst/>
@@ -3473,14 +3530,51 @@
           </a:bodyPr>
           <a:lstStyle/>
           <a:p>
-            <a:r>
-              <a:rPr sz="1700" b="0">
+            <a:pPr>
+              <a:spcAft>
+                <a:spcPts val="600"/>
+              </a:spcAft>
+            </a:pPr>
+            <a:r>
+              <a:rPr sz="1500" b="0">
                 <a:solidFill>
                   <a:srgbClr val="5C6B7A"/>
                 </a:solidFill>
                 <a:latin typeface="Arial"/>
               </a:rPr>
-              <a:t>Paste Compass URL → Generate (photos + facts) → scroll brochure + Google Map → Edit brochure → Print/PDF. Compass RapidAPI only (not Zillow/Redfin). Space: jasonnlim-listing-brochure-studio-jason-realty.static.hf.space</a:t>
+              <a:t>Flow: Paste URL → Scrape (RapidAPI) → Compose magazine layout + Google Map → Edit photos/facts → Letter PDF.</a:t>
+            </a:r>
+          </a:p>
+          <a:p>
+            <a:pPr>
+              <a:spcAft>
+                <a:spcPts val="600"/>
+              </a:spcAft>
+            </a:pPr>
+            <a:r>
+              <a:rPr sz="1500" b="0">
+                <a:solidFill>
+                  <a:srgbClr val="5C6B7A"/>
+                </a:solidFill>
+                <a:latin typeface="Arial"/>
+              </a:rPr>
+              <a:t>Space: jasonnlim-listing-brochure-studio-jason-realty.static.hf.space</a:t>
+            </a:r>
+          </a:p>
+          <a:p>
+            <a:pPr>
+              <a:spcAft>
+                <a:spcPts val="600"/>
+              </a:spcAft>
+            </a:pPr>
+            <a:r>
+              <a:rPr sz="1500" b="0">
+                <a:solidFill>
+                  <a:srgbClr val="5C6B7A"/>
+                </a:solidFill>
+                <a:latin typeface="Arial"/>
+              </a:rPr>
+              <a:t>Talk track: scrape → branded template → human edit → seller-ready PDF. Compass RapidAPI only.</a:t>
             </a:r>
           </a:p>
         </p:txBody>
@@ -3555,7 +3649,7 @@
         <p:spPr>
           <a:xfrm>
             <a:off x="0" y="0"/>
-            <a:ext cx="12191695" cy="91440"/>
+            <a:ext cx="12191695" cy="82296"/>
           </a:xfrm>
           <a:prstGeom prst="rect">
             <a:avLst/>
@@ -3597,8 +3691,8 @@
         </p:nvSpPr>
         <p:spPr>
           <a:xfrm>
-            <a:off x="640080" y="457200"/>
-            <a:ext cx="10515600" cy="365760"/>
+            <a:off x="594360" y="365760"/>
+            <a:ext cx="10789920" cy="320040"/>
           </a:xfrm>
           <a:prstGeom prst="rect">
             <a:avLst/>
@@ -3611,14 +3705,19 @@
           </a:bodyPr>
           <a:lstStyle/>
           <a:p>
-            <a:r>
-              <a:rPr sz="1200" b="1">
+            <a:pPr>
+              <a:spcAft>
+                <a:spcPts val="600"/>
+              </a:spcAft>
+            </a:pPr>
+            <a:r>
+              <a:rPr sz="1100" b="1">
                 <a:solidFill>
                   <a:srgbClr val="1F6F78"/>
                 </a:solidFill>
                 <a:latin typeface="Arial"/>
               </a:rPr>
-              <a:t>WHY IT WINS · HOW TO EXPAND</a:t>
+              <a:t>WHY + EXPAND ARCHITECTURE</a:t>
             </a:r>
           </a:p>
         </p:txBody>
@@ -3631,8 +3730,8 @@
         </p:nvSpPr>
         <p:spPr>
           <a:xfrm>
-            <a:off x="640080" y="1097280"/>
-            <a:ext cx="10515600" cy="1280160"/>
+            <a:off x="594360" y="868680"/>
+            <a:ext cx="10789920" cy="1097280"/>
           </a:xfrm>
           <a:prstGeom prst="rect">
             <a:avLst/>
@@ -3645,14 +3744,19 @@
           </a:bodyPr>
           <a:lstStyle/>
           <a:p>
-            <a:r>
-              <a:rPr sz="2800" b="1">
+            <a:pPr>
+              <a:spcAft>
+                <a:spcPts val="600"/>
+              </a:spcAft>
+            </a:pPr>
+            <a:r>
+              <a:rPr sz="2400" b="1">
                 <a:solidFill>
                   <a:srgbClr val="0B1F33"/>
                 </a:solidFill>
                 <a:latin typeface="Arial"/>
               </a:rPr>
-              <a:t>Beachhead: brochure. Company: listing OS.</a:t>
+              <a:t>Beachhead: brochure. Roadmap: listing OS.</a:t>
             </a:r>
           </a:p>
         </p:txBody>
@@ -3665,8 +3769,8 @@
         </p:nvSpPr>
         <p:spPr>
           <a:xfrm>
-            <a:off x="640080" y="2743200"/>
-            <a:ext cx="10515600" cy="2926080"/>
+            <a:off x="594360" y="2194560"/>
+            <a:ext cx="10789920" cy="3840480"/>
           </a:xfrm>
           <a:prstGeom prst="rect">
             <a:avLst/>
@@ -3679,14 +3783,67 @@
           </a:bodyPr>
           <a:lstStyle/>
           <a:p>
-            <a:r>
-              <a:rPr sz="1700" b="0">
+            <a:pPr>
+              <a:spcAft>
+                <a:spcPts val="600"/>
+              </a:spcAft>
+            </a:pPr>
+            <a:r>
+              <a:rPr sz="1500" b="0">
                 <a:solidFill>
                   <a:srgbClr val="5C6B7A"/>
                 </a:solidFill>
                 <a:latin typeface="Arial"/>
               </a:rPr>
-              <a:t>Why: distribution at listing appointments, workflow wedge, licensed-agent trust, shipped HF Space. Expand: LangSmith to debug import gaps (missing photos/facts) and brochure quality; LLM copy polish; MLS/IDX + seller share links. Ask: design partners + advisors.</a:t>
+              <a:t>Why: listing-appointment distribution · workflow wedge · licensed-agent trust · shipped HF Space.</a:t>
+            </a:r>
+          </a:p>
+          <a:p>
+            <a:pPr>
+              <a:spcAft>
+                <a:spcPts val="600"/>
+              </a:spcAft>
+            </a:pPr>
+            <a:r>
+              <a:rPr sz="1500" b="0">
+                <a:solidFill>
+                  <a:srgbClr val="5C6B7A"/>
+                </a:solidFill>
+                <a:latin typeface="Arial"/>
+              </a:rPr>
+              <a:t>Expand: Observe (LangSmith debug missing photos/facts) → Analyze (API vs brochure gaps) → Generate (LLM copy polish) → Distribute (MLS/IDX, batch, seller links).</a:t>
+            </a:r>
+          </a:p>
+          <a:p>
+            <a:pPr>
+              <a:spcAft>
+                <a:spcPts val="600"/>
+              </a:spcAft>
+            </a:pPr>
+            <a:r>
+              <a:rPr sz="1500" b="0">
+                <a:solidFill>
+                  <a:srgbClr val="5C6B7A"/>
+                </a:solidFill>
+                <a:latin typeface="Arial"/>
+              </a:rPr>
+              <a:t>Pipeline: URL → scrape → normalize → compose template → human edit → PDF/share.</a:t>
+            </a:r>
+          </a:p>
+          <a:p>
+            <a:pPr>
+              <a:spcAft>
+                <a:spcPts val="600"/>
+              </a:spcAft>
+            </a:pPr>
+            <a:r>
+              <a:rPr sz="1500" b="0">
+                <a:solidFill>
+                  <a:srgbClr val="5C6B7A"/>
+                </a:solidFill>
+                <a:latin typeface="Arial"/>
+              </a:rPr>
+              <a:t>Ask: design partners + advisors · jason.lim@compass.com · (510) 480-7191</a:t>
             </a:r>
           </a:p>
         </p:txBody>
@@ -3761,7 +3918,7 @@
         <p:spPr>
           <a:xfrm>
             <a:off x="0" y="0"/>
-            <a:ext cx="137160" cy="6858000"/>
+            <a:ext cx="128016" cy="6858000"/>
           </a:xfrm>
           <a:prstGeom prst="rect">
             <a:avLst/>
@@ -3803,8 +3960,8 @@
         </p:nvSpPr>
         <p:spPr>
           <a:xfrm>
-            <a:off x="640080" y="1280160"/>
-            <a:ext cx="10515600" cy="365760"/>
+            <a:off x="594360" y="822960"/>
+            <a:ext cx="10789920" cy="320040"/>
           </a:xfrm>
           <a:prstGeom prst="rect">
             <a:avLst/>
@@ -3817,8 +3974,13 @@
           </a:bodyPr>
           <a:lstStyle/>
           <a:p>
-            <a:r>
-              <a:rPr sz="1200" b="1">
+            <a:pPr>
+              <a:spcAft>
+                <a:spcPts val="600"/>
+              </a:spcAft>
+            </a:pPr>
+            <a:r>
+              <a:rPr sz="1100" b="1">
                 <a:solidFill>
                   <a:srgbClr val="B08D57"/>
                 </a:solidFill>
@@ -3837,8 +3999,8 @@
         </p:nvSpPr>
         <p:spPr>
           <a:xfrm>
-            <a:off x="640080" y="1920240"/>
-            <a:ext cx="10515600" cy="1463040"/>
+            <a:off x="594360" y="1280160"/>
+            <a:ext cx="10789920" cy="1188720"/>
           </a:xfrm>
           <a:prstGeom prst="rect">
             <a:avLst/>
@@ -3851,14 +4013,19 @@
           </a:bodyPr>
           <a:lstStyle/>
           <a:p>
-            <a:r>
-              <a:rPr sz="3000" b="1">
+            <a:pPr>
+              <a:spcAft>
+                <a:spcPts val="600"/>
+              </a:spcAft>
+            </a:pPr>
+            <a:r>
+              <a:rPr sz="2600" b="1">
                 <a:solidFill>
                   <a:srgbClr val="FFFFFF"/>
                 </a:solidFill>
                 <a:latin typeface="Arial"/>
               </a:rPr>
-              <a:t>Generate the next listing before the open house.</a:t>
+              <a:t>Stop rebuilding every flyer. Input the URL. Edit the template.</a:t>
             </a:r>
           </a:p>
         </p:txBody>
@@ -3871,8 +4038,8 @@
         </p:nvSpPr>
         <p:spPr>
           <a:xfrm>
-            <a:off x="640080" y="3840480"/>
-            <a:ext cx="10515600" cy="1828800"/>
+            <a:off x="594360" y="2743200"/>
+            <a:ext cx="10789920" cy="3200400"/>
           </a:xfrm>
           <a:prstGeom prst="rect">
             <a:avLst/>
@@ -3885,14 +4052,51 @@
           </a:bodyPr>
           <a:lstStyle/>
           <a:p>
-            <a:r>
-              <a:rPr sz="1600" b="0">
+            <a:pPr>
+              <a:spcAft>
+                <a:spcPts val="600"/>
+              </a:spcAft>
+            </a:pPr>
+            <a:r>
+              <a:rPr sz="1500" b="0">
                 <a:solidFill>
                   <a:srgbClr val="E8F2F3"/>
                 </a:solidFill>
                 <a:latin typeface="Arial"/>
               </a:rPr>
-              <a:t>Jason Lim · Compass · DRE #02444964 · jason.lim@compass.com · (510) 480-7191 · jasonlimrealty.com — Questions? Open the Hugging Face Space live.</a:t>
+              <a:t>Generate the next listing before the open house.</a:t>
+            </a:r>
+          </a:p>
+          <a:p>
+            <a:pPr>
+              <a:spcAft>
+                <a:spcPts val="600"/>
+              </a:spcAft>
+            </a:pPr>
+            <a:r>
+              <a:rPr sz="1500" b="0">
+                <a:solidFill>
+                  <a:srgbClr val="E8F2F3"/>
+                </a:solidFill>
+                <a:latin typeface="Arial"/>
+              </a:rPr>
+              <a:t>Jason Lim · Compass REALTOR · DRE #02444964 · jasonlimrealty.com</a:t>
+            </a:r>
+          </a:p>
+          <a:p>
+            <a:pPr>
+              <a:spcAft>
+                <a:spcPts val="600"/>
+              </a:spcAft>
+            </a:pPr>
+            <a:r>
+              <a:rPr sz="1500" b="0">
+                <a:solidFill>
+                  <a:srgbClr val="E8F2F3"/>
+                </a:solidFill>
+                <a:latin typeface="Arial"/>
+              </a:rPr>
+              <a:t>Questions? Leave the Hugging Face Space open.</a:t>
             </a:r>
           </a:p>
         </p:txBody>

</xml_diff>

<commit_message>
Frame VC pitch hook around time and dollar savings
Hook leads with 2–4 hrs / ~$150–$600 labor per brochure vs minutes
on the Space; unit-economics example and investor talk tracks on
demo, expand, and close slides.

Co-authored-by: Jason N. Lim <jhhlim@users.noreply.github.com>
</commit_message>
<xml_diff>
--- a/Jason_Lim_Project_Notes_Demo_10min_VC_Pitch.pptx
+++ b/Jason_Lim_Project_Notes_Demo_10min_VC_Pitch.pptx
@@ -3185,7 +3185,7 @@
         </p:nvSpPr>
         <p:spPr>
           <a:xfrm>
-            <a:off x="594360" y="822960"/>
+            <a:off x="594360" y="777240"/>
             <a:ext cx="10789920" cy="320040"/>
           </a:xfrm>
           <a:prstGeom prst="rect">
@@ -3201,7 +3201,7 @@
           <a:p>
             <a:pPr>
               <a:spcAft>
-                <a:spcPts val="600"/>
+                <a:spcPts val="500"/>
               </a:spcAft>
             </a:pPr>
             <a:r>
@@ -3211,7 +3211,7 @@
                 </a:solidFill>
                 <a:latin typeface="Arial"/>
               </a:rPr>
-              <a:t>HOOK — BEFORE vs AFTER</a:t>
+              <a:t>VC HOOK — TIME &amp; $$</a:t>
             </a:r>
           </a:p>
         </p:txBody>
@@ -3224,8 +3224,8 @@
         </p:nvSpPr>
         <p:spPr>
           <a:xfrm>
-            <a:off x="594360" y="1280160"/>
-            <a:ext cx="10789920" cy="1188720"/>
+            <a:off x="594360" y="1234440"/>
+            <a:ext cx="10789920" cy="1280160"/>
           </a:xfrm>
           <a:prstGeom prst="rect">
             <a:avLst/>
@@ -3240,17 +3240,17 @@
           <a:p>
             <a:pPr>
               <a:spcAft>
-                <a:spcPts val="600"/>
+                <a:spcPts val="500"/>
               </a:spcAft>
             </a:pPr>
             <a:r>
-              <a:rPr sz="2600" b="1">
+              <a:rPr sz="2400" b="1">
                 <a:solidFill>
                   <a:srgbClr val="FFFFFF"/>
                 </a:solidFill>
                 <a:latin typeface="Arial"/>
               </a:rPr>
-              <a:t>From Canva chaos → Compass URL → luxury brochure.</a:t>
+              <a:t>Luxury listing marketing burns hours — and dollars — every week.</a:t>
             </a:r>
           </a:p>
         </p:txBody>
@@ -3279,7 +3279,7 @@
           <a:p>
             <a:pPr>
               <a:spcAft>
-                <a:spcPts val="600"/>
+                <a:spcPts val="500"/>
               </a:spcAft>
             </a:pPr>
             <a:r>
@@ -3289,13 +3289,13 @@
                 </a:solidFill>
                 <a:latin typeface="Arial"/>
               </a:rPr>
-              <a:t>BEFORE (Word/Canva): hunt photos, paste facts, fight templates, rebuild every listing for hours.</a:t>
+              <a:t>Today: 2–4 hrs in Word/Canva per brochure ≈ $150–$600 labor at $75–$150/hr.</a:t>
             </a:r>
           </a:p>
           <a:p>
             <a:pPr>
               <a:spcAft>
-                <a:spcPts val="600"/>
+                <a:spcPts val="500"/>
               </a:spcAft>
             </a:pPr>
             <a:r>
@@ -3305,13 +3305,13 @@
                 </a:solidFill>
                 <a:latin typeface="Arial"/>
               </a:rPr>
-              <a:t>AFTER (HF Space): paste Compass URL → auto-fill branded template with photos/facts → Edit brochure → Print/PDF.</a:t>
+              <a:t>After: paste Compass URL → branded template fills → edit gaps → PDF in minutes (10×+ compression).</a:t>
             </a:r>
           </a:p>
           <a:p>
             <a:pPr>
               <a:spcAft>
-                <a:spcPts val="600"/>
+                <a:spcPts val="500"/>
               </a:spcAft>
             </a:pPr>
             <a:r>
@@ -3321,7 +3321,7 @@
                 </a:solidFill>
                 <a:latin typeface="Arial"/>
               </a:rPr>
-              <a:t>Stop designing from a blank page — input a URL, then edit. Jason Lim · Compass · DRE #02444964</a:t>
+              <a:t>Investor line: turn marketing labor into productized margin. Jason Lim · Compass · DRE #02444964</a:t>
             </a:r>
           </a:p>
         </p:txBody>
@@ -3454,7 +3454,7 @@
           <a:p>
             <a:pPr>
               <a:spcAft>
-                <a:spcPts val="600"/>
+                <a:spcPts val="500"/>
               </a:spcAft>
             </a:pPr>
             <a:r>
@@ -3478,7 +3478,7 @@
         <p:spPr>
           <a:xfrm>
             <a:off x="594360" y="868680"/>
-            <a:ext cx="10789920" cy="1097280"/>
+            <a:ext cx="10789920" cy="1005840"/>
           </a:xfrm>
           <a:prstGeom prst="rect">
             <a:avLst/>
@@ -3493,17 +3493,17 @@
           <a:p>
             <a:pPr>
               <a:spcAft>
-                <a:spcPts val="600"/>
+                <a:spcPts val="500"/>
               </a:spcAft>
             </a:pPr>
             <a:r>
-              <a:rPr sz="2400" b="1">
+              <a:rPr sz="2200" b="1">
                 <a:solidFill>
                   <a:srgbClr val="0B1F33"/>
                 </a:solidFill>
                 <a:latin typeface="Arial"/>
               </a:rPr>
-              <a:t>Screen-share: URL in → brochure out.</a:t>
+              <a:t>Watch minutes replace hours. URL in → brochure out.</a:t>
             </a:r>
           </a:p>
         </p:txBody>
@@ -3516,8 +3516,8 @@
         </p:nvSpPr>
         <p:spPr>
           <a:xfrm>
-            <a:off x="594360" y="2194560"/>
-            <a:ext cx="10789920" cy="3840480"/>
+            <a:off x="594360" y="2103120"/>
+            <a:ext cx="10789920" cy="3931920"/>
           </a:xfrm>
           <a:prstGeom prst="rect">
             <a:avLst/>
@@ -3532,27 +3532,27 @@
           <a:p>
             <a:pPr>
               <a:spcAft>
-                <a:spcPts val="600"/>
+                <a:spcPts val="500"/>
               </a:spcAft>
             </a:pPr>
             <a:r>
-              <a:rPr sz="1500" b="0">
+              <a:rPr sz="1400" b="0">
                 <a:solidFill>
                   <a:srgbClr val="5C6B7A"/>
                 </a:solidFill>
                 <a:latin typeface="Arial"/>
               </a:rPr>
-              <a:t>Flow: Paste URL → Scrape (RapidAPI) → Compose magazine layout + Google Map → Edit photos/facts → Letter PDF.</a:t>
+              <a:t>Paste URL → Scrape → Compose (+ Map) → Edit gaps only → Letter PDF.</a:t>
             </a:r>
           </a:p>
           <a:p>
             <a:pPr>
               <a:spcAft>
-                <a:spcPts val="600"/>
+                <a:spcPts val="500"/>
               </a:spcAft>
             </a:pPr>
             <a:r>
-              <a:rPr sz="1500" b="0">
+              <a:rPr sz="1400" b="0">
                 <a:solidFill>
                   <a:srgbClr val="5C6B7A"/>
                 </a:solidFill>
@@ -3564,17 +3564,17 @@
           <a:p>
             <a:pPr>
               <a:spcAft>
-                <a:spcPts val="600"/>
+                <a:spcPts val="500"/>
               </a:spcAft>
             </a:pPr>
             <a:r>
-              <a:rPr sz="1500" b="0">
+              <a:rPr sz="1400" b="0">
                 <a:solidFill>
                   <a:srgbClr val="5C6B7A"/>
                 </a:solidFill>
                 <a:latin typeface="Arial"/>
               </a:rPr>
-              <a:t>Talk track: scrape → branded template → human edit → seller-ready PDF. Compass RapidAPI only.</a:t>
+              <a:t>VC track: compress $150–$600 brochure labor into a workflow agents run before the open house.</a:t>
             </a:r>
           </a:p>
         </p:txBody>
@@ -3707,7 +3707,7 @@
           <a:p>
             <a:pPr>
               <a:spcAft>
-                <a:spcPts val="600"/>
+                <a:spcPts val="500"/>
               </a:spcAft>
             </a:pPr>
             <a:r>
@@ -3717,7 +3717,7 @@
                 </a:solidFill>
                 <a:latin typeface="Arial"/>
               </a:rPr>
-              <a:t>WHY + EXPAND ARCHITECTURE</a:t>
+              <a:t>WHY VCS CARE · UNIT ECONOMICS · ARCHITECTURE</a:t>
             </a:r>
           </a:p>
         </p:txBody>
@@ -3731,7 +3731,7 @@
         <p:spPr>
           <a:xfrm>
             <a:off x="594360" y="868680"/>
-            <a:ext cx="10789920" cy="1097280"/>
+            <a:ext cx="10789920" cy="1005840"/>
           </a:xfrm>
           <a:prstGeom prst="rect">
             <a:avLst/>
@@ -3746,17 +3746,17 @@
           <a:p>
             <a:pPr>
               <a:spcAft>
-                <a:spcPts val="600"/>
+                <a:spcPts val="500"/>
               </a:spcAft>
             </a:pPr>
             <a:r>
-              <a:rPr sz="2400" b="1">
+              <a:rPr sz="2200" b="1">
                 <a:solidFill>
                   <a:srgbClr val="0B1F33"/>
                 </a:solidFill>
                 <a:latin typeface="Arial"/>
               </a:rPr>
-              <a:t>Beachhead: brochure. Roadmap: listing OS.</a:t>
+              <a:t>Save time now. Expand into a listing OS.</a:t>
             </a:r>
           </a:p>
         </p:txBody>
@@ -3769,8 +3769,8 @@
         </p:nvSpPr>
         <p:spPr>
           <a:xfrm>
-            <a:off x="594360" y="2194560"/>
-            <a:ext cx="10789920" cy="3840480"/>
+            <a:off x="594360" y="2103120"/>
+            <a:ext cx="10789920" cy="3931920"/>
           </a:xfrm>
           <a:prstGeom prst="rect">
             <a:avLst/>
@@ -3785,59 +3785,59 @@
           <a:p>
             <a:pPr>
               <a:spcAft>
-                <a:spcPts val="600"/>
+                <a:spcPts val="500"/>
               </a:spcAft>
             </a:pPr>
             <a:r>
-              <a:rPr sz="1500" b="0">
+              <a:rPr sz="1400" b="0">
                 <a:solidFill>
                   <a:srgbClr val="5C6B7A"/>
                 </a:solidFill>
                 <a:latin typeface="Arial"/>
               </a:rPr>
-              <a:t>Why: listing-appointment distribution · workflow wedge · licensed-agent trust · shipped HF Space.</a:t>
+              <a:t>Why: $ pain is clear · listing-appointment distribution · licensed-agent trust · shipped HF Space.</a:t>
             </a:r>
           </a:p>
           <a:p>
             <a:pPr>
               <a:spcAft>
-                <a:spcPts val="600"/>
+                <a:spcPts val="500"/>
               </a:spcAft>
             </a:pPr>
             <a:r>
-              <a:rPr sz="1500" b="0">
+              <a:rPr sz="1400" b="0">
                 <a:solidFill>
                   <a:srgbClr val="5C6B7A"/>
                 </a:solidFill>
                 <a:latin typeface="Arial"/>
               </a:rPr>
-              <a:t>Expand: Observe (LangSmith debug missing photos/facts) → Analyze (API vs brochure gaps) → Generate (LLM copy polish) → Distribute (MLS/IDX, batch, seller links).</a:t>
+              <a:t>Example: 8 listings/mo × 3 hrs × $100/hr ≈ $2,400/mo unlocked per agent (illustrative).</a:t>
             </a:r>
           </a:p>
           <a:p>
             <a:pPr>
               <a:spcAft>
-                <a:spcPts val="600"/>
+                <a:spcPts val="500"/>
               </a:spcAft>
             </a:pPr>
             <a:r>
-              <a:rPr sz="1500" b="0">
+              <a:rPr sz="1400" b="0">
                 <a:solidFill>
                   <a:srgbClr val="5C6B7A"/>
                 </a:solidFill>
                 <a:latin typeface="Arial"/>
               </a:rPr>
-              <a:t>Pipeline: URL → scrape → normalize → compose template → human edit → PDF/share.</a:t>
+              <a:t>Expand: Observe (LangSmith debug imports) → Analyze (API vs brochure) → Generate (LLM polish) → Distribute (MLS, batch, seller links).</a:t>
             </a:r>
           </a:p>
           <a:p>
             <a:pPr>
               <a:spcAft>
-                <a:spcPts val="600"/>
+                <a:spcPts val="500"/>
               </a:spcAft>
             </a:pPr>
             <a:r>
-              <a:rPr sz="1500" b="0">
+              <a:rPr sz="1400" b="0">
                 <a:solidFill>
                   <a:srgbClr val="5C6B7A"/>
                 </a:solidFill>
@@ -3960,7 +3960,7 @@
         </p:nvSpPr>
         <p:spPr>
           <a:xfrm>
-            <a:off x="594360" y="822960"/>
+            <a:off x="594360" y="777240"/>
             <a:ext cx="10789920" cy="320040"/>
           </a:xfrm>
           <a:prstGeom prst="rect">
@@ -3976,7 +3976,7 @@
           <a:p>
             <a:pPr>
               <a:spcAft>
-                <a:spcPts val="600"/>
+                <a:spcPts val="500"/>
               </a:spcAft>
             </a:pPr>
             <a:r>
@@ -3999,8 +3999,8 @@
         </p:nvSpPr>
         <p:spPr>
           <a:xfrm>
-            <a:off x="594360" y="1280160"/>
-            <a:ext cx="10789920" cy="1188720"/>
+            <a:off x="594360" y="1234440"/>
+            <a:ext cx="10789920" cy="1280160"/>
           </a:xfrm>
           <a:prstGeom prst="rect">
             <a:avLst/>
@@ -4015,17 +4015,17 @@
           <a:p>
             <a:pPr>
               <a:spcAft>
-                <a:spcPts val="600"/>
+                <a:spcPts val="500"/>
               </a:spcAft>
             </a:pPr>
             <a:r>
-              <a:rPr sz="2600" b="1">
+              <a:rPr sz="2400" b="1">
                 <a:solidFill>
                   <a:srgbClr val="FFFFFF"/>
                 </a:solidFill>
                 <a:latin typeface="Arial"/>
               </a:rPr>
-              <a:t>Stop rebuilding every flyer. Input the URL. Edit the template.</a:t>
+              <a:t>Stop paying hours for every flyer. Input the URL. Edit the template. Keep the margin.</a:t>
             </a:r>
           </a:p>
         </p:txBody>
@@ -4054,7 +4054,7 @@
           <a:p>
             <a:pPr>
               <a:spcAft>
-                <a:spcPts val="600"/>
+                <a:spcPts val="500"/>
               </a:spcAft>
             </a:pPr>
             <a:r>
@@ -4064,13 +4064,13 @@
                 </a:solidFill>
                 <a:latin typeface="Arial"/>
               </a:rPr>
-              <a:t>Generate the next listing before the open house.</a:t>
+              <a:t>Jason Lim · Compass · DRE #02444964 · jasonlimrealty.com</a:t>
             </a:r>
           </a:p>
           <a:p>
             <a:pPr>
               <a:spcAft>
-                <a:spcPts val="600"/>
+                <a:spcPts val="500"/>
               </a:spcAft>
             </a:pPr>
             <a:r>
@@ -4080,23 +4080,7 @@
                 </a:solidFill>
                 <a:latin typeface="Arial"/>
               </a:rPr>
-              <a:t>Jason Lim · Compass REALTOR · DRE #02444964 · jasonlimrealty.com</a:t>
-            </a:r>
-          </a:p>
-          <a:p>
-            <a:pPr>
-              <a:spcAft>
-                <a:spcPts val="600"/>
-              </a:spcAft>
-            </a:pPr>
-            <a:r>
-              <a:rPr sz="1500" b="0">
-                <a:solidFill>
-                  <a:srgbClr val="E8F2F3"/>
-                </a:solidFill>
-                <a:latin typeface="Arial"/>
-              </a:rPr>
-              <a:t>Questions? Leave the Hugging Face Space open.</a:t>
+              <a:t>Questions? Leave the HF Space open — show the minutes vs the hours.</a:t>
             </a:r>
           </a:p>
         </p:txBody>

</xml_diff>

<commit_message>
Make slide 2 audience-facing product story
Remove talk-track and live-demo presenter notes from the second
slide; keep workflow, value props, and Space URL for investors.

Co-authored-by: Jason N. Lim <jhhlim@users.noreply.github.com>
</commit_message>
<xml_diff>
--- a/Jason_Lim_Project_Notes_Demo_10min_VC_Pitch.pptx
+++ b/Jason_Lim_Project_Notes_Demo_10min_VC_Pitch.pptx
@@ -3321,7 +3321,7 @@
                 </a:solidFill>
                 <a:latin typeface="Arial"/>
               </a:rPr>
-              <a:t>Investor line: turn marketing labor into productized margin. Jason Lim · Compass · DRE #02444964</a:t>
+              <a:t>Turn marketing labor into productized margin. Jason Lim · Compass · DRE #02444964</a:t>
             </a:r>
           </a:p>
         </p:txBody>
@@ -3464,7 +3464,7 @@
                 </a:solidFill>
                 <a:latin typeface="Arial"/>
               </a:rPr>
-              <a:t>LIVE DEMO — HUGGING FACE</a:t>
+              <a:t>THE PRODUCT</a:t>
             </a:r>
           </a:p>
         </p:txBody>
@@ -3503,7 +3503,7 @@
                 </a:solidFill>
                 <a:latin typeface="Arial"/>
               </a:rPr>
-              <a:t>Watch minutes replace hours. URL in → brochure out.</a:t>
+              <a:t>Compass URL in. Luxury brochure out — in minutes.</a:t>
             </a:r>
           </a:p>
         </p:txBody>
@@ -3542,7 +3542,7 @@
                 </a:solidFill>
                 <a:latin typeface="Arial"/>
               </a:rPr>
-              <a:t>Paste URL → Scrape → Compose (+ Map) → Edit gaps only → Letter PDF.</a:t>
+              <a:t>Paste URL → ingest photos/facts → compose luxury layout + map → refine edits → Letter PDF.</a:t>
             </a:r>
           </a:p>
           <a:p>
@@ -3558,7 +3558,7 @@
                 </a:solidFill>
                 <a:latin typeface="Arial"/>
               </a:rPr>
-              <a:t>Space: jasonnlim-listing-brochure-studio-jason-realty.static.hf.space</a:t>
+              <a:t>Agents and sellers get: minutes instead of hours, on-brand presentation, editable photos/facts, Print/PDF.</a:t>
             </a:r>
           </a:p>
           <a:p>
@@ -3574,7 +3574,7 @@
                 </a:solidFill>
                 <a:latin typeface="Arial"/>
               </a:rPr>
-              <a:t>VC track: compress $150–$600 brochure labor into a workflow agents run before the open house.</a:t>
+              <a:t>Live: jasonnlim-listing-brochure-studio-jason-realty.static.hf.space</a:t>
             </a:r>
           </a:p>
         </p:txBody>
@@ -3717,7 +3717,7 @@
                 </a:solidFill>
                 <a:latin typeface="Arial"/>
               </a:rPr>
-              <a:t>WHY VCS CARE · UNIT ECONOMICS · ARCHITECTURE</a:t>
+              <a:t>WHY IT’S INVESTABLE · ECONOMICS · EXPANSION</a:t>
             </a:r>
           </a:p>
         </p:txBody>
@@ -3795,7 +3795,7 @@
                 </a:solidFill>
                 <a:latin typeface="Arial"/>
               </a:rPr>
-              <a:t>Why: $ pain is clear · listing-appointment distribution · licensed-agent trust · shipped HF Space.</a:t>
+              <a:t>Why: clear $ pain · listing-appointment distribution · licensed-agent trust · shipped HF Space.</a:t>
             </a:r>
           </a:p>
           <a:p>
@@ -3827,7 +3827,7 @@
                 </a:solidFill>
                 <a:latin typeface="Arial"/>
               </a:rPr>
-              <a:t>Expand: Observe (LangSmith debug imports) → Analyze (API vs brochure) → Generate (LLM polish) → Distribute (MLS, batch, seller links).</a:t>
+              <a:t>Expand: Observe (LangSmith debug imports) → Analyze → Generate (LLM polish) → Distribute (MLS, batch, seller links).</a:t>
             </a:r>
           </a:p>
           <a:p>
@@ -4080,7 +4080,7 @@
                 </a:solidFill>
                 <a:latin typeface="Arial"/>
               </a:rPr>
-              <a:t>Questions? Leave the HF Space open — show the minutes vs the hours.</a:t>
+              <a:t>Let’s generate the next listing before the open house.</a:t>
             </a:r>
           </a:p>
         </p:txBody>

</xml_diff>

<commit_message>
Reframe pitch as B2B brochure product for brokerages
Drop personal Compass/site “why it wins” on slide 3; target RE
company tech/marketing and realtors. Soften slide 4 close — no
leave-the-Space language.

Co-authored-by: Jason N. Lim <jhhlim@users.noreply.github.com>
</commit_message>
<xml_diff>
--- a/Jason_Lim_Project_Notes_Demo_10min_VC_Pitch.pptx
+++ b/Jason_Lim_Project_Notes_Demo_10min_VC_Pitch.pptx
@@ -3289,7 +3289,7 @@
                 </a:solidFill>
                 <a:latin typeface="Arial"/>
               </a:rPr>
-              <a:t>Today: 2–4 hrs in Word/Canva per brochure ≈ $150–$600 labor at $75–$150/hr.</a:t>
+              <a:t>Today: 2–4 hrs in Word/Canva ≈ $150–$600 labor per listing.</a:t>
             </a:r>
           </a:p>
           <a:p>
@@ -3305,7 +3305,7 @@
                 </a:solidFill>
                 <a:latin typeface="Arial"/>
               </a:rPr>
-              <a:t>After: paste Compass URL → branded template fills → edit gaps → PDF in minutes (10×+ compression).</a:t>
+              <a:t>After: paste listing URL → branded template → edit gaps → PDF in minutes.</a:t>
             </a:r>
           </a:p>
           <a:p>
@@ -3321,7 +3321,7 @@
                 </a:solidFill>
                 <a:latin typeface="Arial"/>
               </a:rPr>
-              <a:t>Turn marketing labor into productized margin. Jason Lim · Compass · DRE #02444964</a:t>
+              <a:t>Sellable to brokerages, proptech, and agent networks — productize marketing labor.</a:t>
             </a:r>
           </a:p>
         </p:txBody>
@@ -3503,7 +3503,7 @@
                 </a:solidFill>
                 <a:latin typeface="Arial"/>
               </a:rPr>
-              <a:t>Compass URL in. Luxury brochure out — in minutes.</a:t>
+              <a:t>Listing URL in. Luxury brochure out — in minutes.</a:t>
             </a:r>
           </a:p>
         </p:txBody>
@@ -3542,7 +3542,7 @@
                 </a:solidFill>
                 <a:latin typeface="Arial"/>
               </a:rPr>
-              <a:t>Paste URL → ingest photos/facts → compose luxury layout + map → refine edits → Letter PDF.</a:t>
+              <a:t>Paste URL → ingest photos/facts → compose layout + map → refine → Letter PDF.</a:t>
             </a:r>
           </a:p>
           <a:p>
@@ -3558,7 +3558,7 @@
                 </a:solidFill>
                 <a:latin typeface="Arial"/>
               </a:rPr>
-              <a:t>Agents and sellers get: minutes instead of hours, on-brand presentation, editable photos/facts, Print/PDF.</a:t>
+              <a:t>Brokerages and agents get: speed, brand consistency, editable photos/facts, Print/PDF.</a:t>
             </a:r>
           </a:p>
           <a:p>
@@ -3574,7 +3574,7 @@
                 </a:solidFill>
                 <a:latin typeface="Arial"/>
               </a:rPr>
-              <a:t>Live: jasonnlim-listing-brochure-studio-jason-realty.static.hf.space</a:t>
+              <a:t>Built for real-estate company tech/marketing teams and realtor workflows.</a:t>
             </a:r>
           </a:p>
         </p:txBody>
@@ -3717,7 +3717,7 @@
                 </a:solidFill>
                 <a:latin typeface="Arial"/>
               </a:rPr>
-              <a:t>WHY IT’S INVESTABLE · ECONOMICS · EXPANSION</a:t>
+              <a:t>BUYERS · ECONOMICS · EXPANSION</a:t>
             </a:r>
           </a:p>
         </p:txBody>
@@ -3756,7 +3756,7 @@
                 </a:solidFill>
                 <a:latin typeface="Arial"/>
               </a:rPr>
-              <a:t>Save time now. Expand into a listing OS.</a:t>
+              <a:t>Who buys this — and how we expand the product.</a:t>
             </a:r>
           </a:p>
         </p:txBody>
@@ -3795,7 +3795,7 @@
                 </a:solidFill>
                 <a:latin typeface="Arial"/>
               </a:rPr>
-              <a:t>Why: clear $ pain · listing-appointment distribution · licensed-agent trust · shipped HF Space.</a:t>
+              <a:t>Buyers: brokerage tech &amp; marketing · proptech platforms · independent realtors · white-label brand kits.</a:t>
             </a:r>
           </a:p>
           <a:p>
@@ -3811,7 +3811,7 @@
                 </a:solidFill>
                 <a:latin typeface="Arial"/>
               </a:rPr>
-              <a:t>Example: 8 listings/mo × 3 hrs × $100/hr ≈ $2,400/mo unlocked per agent (illustrative).</a:t>
+              <a:t>Economics: minutes vs hours; ~$2,400/mo unlocked per agent at 8 listings × 3 hrs × $100/hr (illustrative).</a:t>
             </a:r>
           </a:p>
           <a:p>
@@ -3827,7 +3827,7 @@
                 </a:solidFill>
                 <a:latin typeface="Arial"/>
               </a:rPr>
-              <a:t>Expand: Observe (LangSmith debug imports) → Analyze → Generate (LLM polish) → Distribute (MLS, batch, seller links).</a:t>
+              <a:t>Expand: Observe (trace import gaps) → Analyze (completeness) → Generate (LLM polish) → Distribute (MLS, batch, seller links, white-label).</a:t>
             </a:r>
           </a:p>
           <a:p>
@@ -3843,7 +3843,7 @@
                 </a:solidFill>
                 <a:latin typeface="Arial"/>
               </a:rPr>
-              <a:t>Ask: design partners + advisors · jason.lim@compass.com · (510) 480-7191</a:t>
+              <a:t>Ask: design partners · pilot teams inside real-estate companies · advisors.</a:t>
             </a:r>
           </a:p>
         </p:txBody>
@@ -4064,7 +4064,7 @@
                 </a:solidFill>
                 <a:latin typeface="Arial"/>
               </a:rPr>
-              <a:t>Jason Lim · Compass · DRE #02444964 · jasonlimrealty.com</a:t>
+              <a:t>A brochure engine for brokerages, proptech, and realtors.</a:t>
             </a:r>
           </a:p>
           <a:p>

</xml_diff>